<commit_message>
Reformula objetivos geral e específicos e atualiza indicadores
Co-Authored-By: Claude Sonnet 5.5 <noreply@anthropic.com>
Claude-Session: https://claude.ai/code/session_018oVMGfcbhG1itrwj795JhB
</commit_message>
<xml_diff>
--- a/Baterias_SIN_Economia_Setor_Eletrico_I.pptx
+++ b/Baterias_SIN_Economia_Setor_Eletrico_I.pptx
@@ -121,12 +121,12 @@
   <p:extLst>
     <p:ext uri="{521415D9-36F7-43E2-AB2F-B90AF26B5E84}">
       <p14:sectionLst xmlns:p14="http://schemas.microsoft.com/office/powerpoint/2010/main">
-        <p14:section name="Abertura" id="{9a0fbf1f-498b-a105-d8c4-e321a4530428}">
+        <p14:section name="Abertura" id="{a85628f9-75e7-075f-a306-1f8cf666f13e}">
           <p14:sldIdLst>
             <p14:sldId id="256"/>
           </p14:sldIdLst>
         </p14:section>
-        <p14:section name="Introdução" id="{d208181f-e6d8-59bf-8df5-2838b1307c78}">
+        <p14:section name="Introdução" id="{ab0bd54b-b354-a689-3d6c-2fa5098d71df}">
           <p14:sldIdLst>
             <p14:sldId id="257"/>
             <p14:sldId id="258"/>
@@ -134,13 +134,13 @@
             <p14:sldId id="260"/>
           </p14:sldIdLst>
         </p14:section>
-        <p14:section name="Objetivos" id="{c9dde1c5-58e0-5602-cd3e-2f6668ce6d20}">
+        <p14:section name="Objetivos" id="{4556daed-491e-7b07-4bab-df590511e6c9}">
           <p14:sldIdLst>
             <p14:sldId id="261"/>
             <p14:sldId id="262"/>
           </p14:sldIdLst>
         </p14:section>
-        <p14:section name="Método" id="{66048603-3e36-c244-63a5-f702bb4db51d}">
+        <p14:section name="Método" id="{21ddb656-e38e-9c13-4ae2-8b23d795d092}">
           <p14:sldIdLst>
             <p14:sldId id="263"/>
             <p14:sldId id="264"/>
@@ -148,14 +148,14 @@
             <p14:sldId id="266"/>
           </p14:sldIdLst>
         </p14:section>
-        <p14:section name="Análise" id="{f5414e24-f20b-8b06-d46b-4605979fbb8d}">
+        <p14:section name="Análise" id="{82c8d00c-77f6-9648-fca7-d10aff6001f0}">
           <p14:sldIdLst>
             <p14:sldId id="267"/>
             <p14:sldId id="268"/>
             <p14:sldId id="269"/>
           </p14:sldIdLst>
         </p14:section>
-        <p14:section name="Referências" id="{6884f414-8b62-e3d0-0a3e-c734bcb2c5b8}">
+        <p14:section name="Referências" id="{a855a8d2-c74c-d247-62a4-37029c857692}">
           <p14:sldIdLst>
             <p14:sldId id="270"/>
           </p14:sldIdLst>
@@ -1620,7 +1620,7 @@
           <a:p>
             <a:r>
               <a:rPr lang="en-US" dirty="0"/>
-              <a:t>Cinco objetivos específicos, cada um ligado a uma variável de saída da simulação. OE1 a OE4 vêm das simulações; OE5 depende do cálculo dos encargos por fonte.</a:t>
+              <a:t>Os cinco objetivos específicos formam uma cadeia: efeitos das baterias (OE1 e OE2), ganho sistêmico (OE3), custo (OE4) e comparação final (OE5), que responde à pergunta de pesquisa.</a:t>
             </a:r>
             <a:endParaRPr lang="en-US" dirty="0"/>
           </a:p>
@@ -4807,7 +4807,7 @@
                           <a:ea typeface="Calibri" pitchFamily="34" charset="-122"/>
                           <a:cs typeface="Calibri" pitchFamily="34" charset="-120"/>
                         </a:rPr>
-                        <a:t>Sem × com BESS, por cenário</a:t>
+                        <a:t>Sem × com BESS, por nível de MMGD</a:t>
                       </a:r>
                       <a:endParaRPr lang="en-US" sz="1400" dirty="0">
                         <a:latin typeface="Calibri" charset="0"/>
@@ -4945,7 +4945,7 @@
                           <a:ea typeface="Calibri" pitchFamily="34" charset="-122"/>
                           <a:cs typeface="Calibri" pitchFamily="34" charset="-120"/>
                         </a:rPr>
-                        <a:t>Despacho de UHEs, UTEs, UFVs e eólicas</a:t>
+                        <a:t>Despacho por fonte e energia armazenada nas UHEs</a:t>
                       </a:r>
                       <a:endParaRPr lang="en-US" sz="1400" dirty="0">
                         <a:latin typeface="Calibri" charset="0"/>
@@ -5013,7 +5013,7 @@
                           <a:ea typeface="Calibri" pitchFamily="34" charset="-122"/>
                           <a:cs typeface="Calibri" pitchFamily="34" charset="-120"/>
                         </a:rPr>
-                        <a:t>MWh/ano e MW médios horários</a:t>
+                        <a:t>MWh/ano, MW médios e % da capacidade</a:t>
                       </a:r>
                       <a:endParaRPr lang="en-US" sz="1400" dirty="0">
                         <a:latin typeface="Calibri" charset="0"/>
@@ -5152,280 +5152,6 @@
                           <a:cs typeface="Calibri" pitchFamily="34" charset="-120"/>
                         </a:rPr>
                         <a:t>OE3</a:t>
-                      </a:r>
-                      <a:endParaRPr lang="en-US" sz="1400" dirty="0">
-                        <a:latin typeface="Calibri" charset="0"/>
-                        <a:ea typeface="Calibri" charset="0"/>
-                        <a:cs typeface="Calibri" charset="0"/>
-                      </a:endParaRPr>
-                    </a:p>
-                  </a:txBody>
-                  <a:tcPr marL="137160" marR="137160" marT="45720" marB="45720" anchor="ctr">
-                    <a:lnL w="12700" cap="flat" cmpd="sng" algn="ctr">
-                      <a:solidFill>
-                        <a:srgbClr val="EEF3F8"/>
-                      </a:solidFill>
-                      <a:prstDash val="solid"/>
-                      <a:round/>
-                      <a:headEnd type="none" w="med" len="med"/>
-                      <a:tailEnd type="none" w="med" len="med"/>
-                    </a:lnL>
-                    <a:lnR w="12700" cap="flat" cmpd="sng" algn="ctr">
-                      <a:solidFill>
-                        <a:srgbClr val="EEF3F8"/>
-                      </a:solidFill>
-                      <a:prstDash val="solid"/>
-                      <a:round/>
-                      <a:headEnd type="none" w="med" len="med"/>
-                      <a:tailEnd type="none" w="med" len="med"/>
-                    </a:lnR>
-                    <a:lnT w="12700" cap="flat" cmpd="sng" algn="ctr">
-                      <a:solidFill>
-                        <a:srgbClr val="EEF3F8"/>
-                      </a:solidFill>
-                      <a:prstDash val="solid"/>
-                      <a:round/>
-                      <a:headEnd type="none" w="med" len="med"/>
-                      <a:tailEnd type="none" w="med" len="med"/>
-                    </a:lnT>
-                    <a:lnB w="12700" cap="flat" cmpd="sng" algn="ctr">
-                      <a:solidFill>
-                        <a:srgbClr val="EEF3F8"/>
-                      </a:solidFill>
-                      <a:prstDash val="solid"/>
-                      <a:round/>
-                      <a:headEnd type="none" w="med" len="med"/>
-                      <a:tailEnd type="none" w="med" len="med"/>
-                    </a:lnB>
-                    <a:solidFill>
-                      <a:schemeClr val="bg1"/>
-                    </a:solidFill>
-                  </a:tcPr>
-                </a:tc>
-                <a:tc>
-                  <a:txBody>
-                    <a:bodyPr/>
-                    <a:lstStyle/>
-                    <a:p>
-                      <a:pPr indent="0" marL="0">
-                        <a:buNone/>
-                      </a:pPr>
-                      <a:r>
-                        <a:rPr lang="en-US" sz="1400" dirty="0">
-                          <a:solidFill>
-                            <a:schemeClr val="tx1"/>
-                          </a:solidFill>
-                          <a:latin typeface="Calibri" pitchFamily="34" charset="0"/>
-                          <a:ea typeface="Calibri" pitchFamily="34" charset="-122"/>
-                          <a:cs typeface="Calibri" pitchFamily="34" charset="-120"/>
-                        </a:rPr>
-                        <a:t>Energia armazenada nas UHEs</a:t>
-                      </a:r>
-                      <a:endParaRPr lang="en-US" sz="1400" dirty="0">
-                        <a:latin typeface="Calibri" charset="0"/>
-                        <a:ea typeface="Calibri" charset="0"/>
-                        <a:cs typeface="Calibri" charset="0"/>
-                      </a:endParaRPr>
-                    </a:p>
-                  </a:txBody>
-                  <a:tcPr marL="137160" marR="137160" marT="45720" marB="45720" anchor="ctr">
-                    <a:lnL w="12700" cap="flat" cmpd="sng" algn="ctr">
-                      <a:solidFill>
-                        <a:srgbClr val="EEF3F8"/>
-                      </a:solidFill>
-                      <a:prstDash val="solid"/>
-                      <a:round/>
-                      <a:headEnd type="none" w="med" len="med"/>
-                      <a:tailEnd type="none" w="med" len="med"/>
-                    </a:lnL>
-                    <a:lnR w="12700" cap="flat" cmpd="sng" algn="ctr">
-                      <a:solidFill>
-                        <a:srgbClr val="EEF3F8"/>
-                      </a:solidFill>
-                      <a:prstDash val="solid"/>
-                      <a:round/>
-                      <a:headEnd type="none" w="med" len="med"/>
-                      <a:tailEnd type="none" w="med" len="med"/>
-                    </a:lnR>
-                    <a:lnT w="12700" cap="flat" cmpd="sng" algn="ctr">
-                      <a:solidFill>
-                        <a:srgbClr val="EEF3F8"/>
-                      </a:solidFill>
-                      <a:prstDash val="solid"/>
-                      <a:round/>
-                      <a:headEnd type="none" w="med" len="med"/>
-                      <a:tailEnd type="none" w="med" len="med"/>
-                    </a:lnT>
-                    <a:lnB w="12700" cap="flat" cmpd="sng" algn="ctr">
-                      <a:solidFill>
-                        <a:srgbClr val="EEF3F8"/>
-                      </a:solidFill>
-                      <a:prstDash val="solid"/>
-                      <a:round/>
-                      <a:headEnd type="none" w="med" len="med"/>
-                      <a:tailEnd type="none" w="med" len="med"/>
-                    </a:lnB>
-                    <a:solidFill>
-                      <a:schemeClr val="bg1"/>
-                    </a:solidFill>
-                  </a:tcPr>
-                </a:tc>
-                <a:tc>
-                  <a:txBody>
-                    <a:bodyPr/>
-                    <a:lstStyle/>
-                    <a:p>
-                      <a:pPr indent="0" marL="0">
-                        <a:buNone/>
-                      </a:pPr>
-                      <a:r>
-                        <a:rPr lang="en-US" sz="1400" dirty="0">
-                          <a:solidFill>
-                            <a:schemeClr val="tx1"/>
-                          </a:solidFill>
-                          <a:latin typeface="Calibri" pitchFamily="34" charset="0"/>
-                          <a:ea typeface="Calibri" pitchFamily="34" charset="-122"/>
-                          <a:cs typeface="Calibri" pitchFamily="34" charset="-120"/>
-                        </a:rPr>
-                        <a:t>% da capacidade, mensal</a:t>
-                      </a:r>
-                      <a:endParaRPr lang="en-US" sz="1400" dirty="0">
-                        <a:latin typeface="Calibri" charset="0"/>
-                        <a:ea typeface="Calibri" charset="0"/>
-                        <a:cs typeface="Calibri" charset="0"/>
-                      </a:endParaRPr>
-                    </a:p>
-                  </a:txBody>
-                  <a:tcPr marL="137160" marR="137160" marT="45720" marB="45720" anchor="ctr">
-                    <a:lnL w="12700" cap="flat" cmpd="sng" algn="ctr">
-                      <a:solidFill>
-                        <a:srgbClr val="EEF3F8"/>
-                      </a:solidFill>
-                      <a:prstDash val="solid"/>
-                      <a:round/>
-                      <a:headEnd type="none" w="med" len="med"/>
-                      <a:tailEnd type="none" w="med" len="med"/>
-                    </a:lnL>
-                    <a:lnR w="12700" cap="flat" cmpd="sng" algn="ctr">
-                      <a:solidFill>
-                        <a:srgbClr val="EEF3F8"/>
-                      </a:solidFill>
-                      <a:prstDash val="solid"/>
-                      <a:round/>
-                      <a:headEnd type="none" w="med" len="med"/>
-                      <a:tailEnd type="none" w="med" len="med"/>
-                    </a:lnR>
-                    <a:lnT w="12700" cap="flat" cmpd="sng" algn="ctr">
-                      <a:solidFill>
-                        <a:srgbClr val="EEF3F8"/>
-                      </a:solidFill>
-                      <a:prstDash val="solid"/>
-                      <a:round/>
-                      <a:headEnd type="none" w="med" len="med"/>
-                      <a:tailEnd type="none" w="med" len="med"/>
-                    </a:lnT>
-                    <a:lnB w="12700" cap="flat" cmpd="sng" algn="ctr">
-                      <a:solidFill>
-                        <a:srgbClr val="EEF3F8"/>
-                      </a:solidFill>
-                      <a:prstDash val="solid"/>
-                      <a:round/>
-                      <a:headEnd type="none" w="med" len="med"/>
-                      <a:tailEnd type="none" w="med" len="med"/>
-                    </a:lnB>
-                    <a:solidFill>
-                      <a:schemeClr val="bg1"/>
-                    </a:solidFill>
-                  </a:tcPr>
-                </a:tc>
-                <a:tc>
-                  <a:txBody>
-                    <a:bodyPr/>
-                    <a:lstStyle/>
-                    <a:p>
-                      <a:pPr indent="0" marL="0">
-                        <a:buNone/>
-                      </a:pPr>
-                      <a:r>
-                        <a:rPr lang="en-US" sz="1400" dirty="0">
-                          <a:solidFill>
-                            <a:schemeClr val="tx1"/>
-                          </a:solidFill>
-                          <a:latin typeface="Calibri" pitchFamily="34" charset="0"/>
-                          <a:ea typeface="Calibri" pitchFamily="34" charset="-122"/>
-                          <a:cs typeface="Calibri" pitchFamily="34" charset="-120"/>
-                        </a:rPr>
-                        <a:t>Trajetória sem × com BESS</a:t>
-                      </a:r>
-                      <a:endParaRPr lang="en-US" sz="1400" dirty="0">
-                        <a:latin typeface="Calibri" charset="0"/>
-                        <a:ea typeface="Calibri" charset="0"/>
-                        <a:cs typeface="Calibri" charset="0"/>
-                      </a:endParaRPr>
-                    </a:p>
-                  </a:txBody>
-                  <a:tcPr marL="137160" marR="137160" marT="45720" marB="45720" anchor="ctr">
-                    <a:lnL w="12700" cap="flat" cmpd="sng" algn="ctr">
-                      <a:solidFill>
-                        <a:srgbClr val="EEF3F8"/>
-                      </a:solidFill>
-                      <a:prstDash val="solid"/>
-                      <a:round/>
-                      <a:headEnd type="none" w="med" len="med"/>
-                      <a:tailEnd type="none" w="med" len="med"/>
-                    </a:lnL>
-                    <a:lnR w="12700" cap="flat" cmpd="sng" algn="ctr">
-                      <a:solidFill>
-                        <a:srgbClr val="EEF3F8"/>
-                      </a:solidFill>
-                      <a:prstDash val="solid"/>
-                      <a:round/>
-                      <a:headEnd type="none" w="med" len="med"/>
-                      <a:tailEnd type="none" w="med" len="med"/>
-                    </a:lnR>
-                    <a:lnT w="12700" cap="flat" cmpd="sng" algn="ctr">
-                      <a:solidFill>
-                        <a:srgbClr val="EEF3F8"/>
-                      </a:solidFill>
-                      <a:prstDash val="solid"/>
-                      <a:round/>
-                      <a:headEnd type="none" w="med" len="med"/>
-                      <a:tailEnd type="none" w="med" len="med"/>
-                    </a:lnT>
-                    <a:lnB w="12700" cap="flat" cmpd="sng" algn="ctr">
-                      <a:solidFill>
-                        <a:srgbClr val="EEF3F8"/>
-                      </a:solidFill>
-                      <a:prstDash val="solid"/>
-                      <a:round/>
-                      <a:headEnd type="none" w="med" len="med"/>
-                      <a:tailEnd type="none" w="med" len="med"/>
-                    </a:lnB>
-                    <a:solidFill>
-                      <a:schemeClr val="bg1"/>
-                    </a:solidFill>
-                  </a:tcPr>
-                </a:tc>
-              </a:tr>
-              <a:tr h="713232">
-                <a:tc>
-                  <a:txBody>
-                    <a:bodyPr/>
-                    <a:lstStyle/>
-                    <a:p>
-                      <a:pPr indent="0" marL="0">
-                        <a:buNone/>
-                      </a:pPr>
-                      <a:r>
-                        <a:rPr lang="en-US" sz="1400" b="1" dirty="0">
-                          <a:solidFill>
-                            <a:schemeClr val="tx1"/>
-                          </a:solidFill>
-                          <a:latin typeface="Calibri" pitchFamily="34" charset="0"/>
-                          <a:ea typeface="Calibri" pitchFamily="34" charset="-122"/>
-                          <a:cs typeface="Calibri" pitchFamily="34" charset="-120"/>
-                        </a:rPr>
-                        <a:t>OE4</a:t>
                       </a:r>
                       <a:endParaRPr lang="en-US" sz="1400" dirty="0">
                         <a:latin typeface="Calibri" charset="0"/>
@@ -5699,7 +5425,7 @@
                           <a:ea typeface="Calibri" pitchFamily="34" charset="-122"/>
                           <a:cs typeface="Calibri" pitchFamily="34" charset="-120"/>
                         </a:rPr>
-                        <a:t>OE5</a:t>
+                        <a:t>OE4</a:t>
                       </a:r>
                       <a:endParaRPr lang="en-US" sz="1400" dirty="0">
                         <a:latin typeface="Calibri" charset="0"/>
@@ -5903,7 +5629,281 @@
                           <a:ea typeface="Calibri" pitchFamily="34" charset="-122"/>
                           <a:cs typeface="Calibri" pitchFamily="34" charset="-120"/>
                         </a:rPr>
-                        <a:t>ΔCTO ÷ Σ encargos ≥ 1?</a:t>
+                        <a:t>Conforme a regra de rateio</a:t>
+                      </a:r>
+                      <a:endParaRPr lang="en-US" sz="1400" dirty="0">
+                        <a:latin typeface="Calibri" charset="0"/>
+                        <a:ea typeface="Calibri" charset="0"/>
+                        <a:cs typeface="Calibri" charset="0"/>
+                      </a:endParaRPr>
+                    </a:p>
+                  </a:txBody>
+                  <a:tcPr marL="137160" marR="137160" marT="45720" marB="45720" anchor="ctr">
+                    <a:lnL w="12700" cap="flat" cmpd="sng" algn="ctr">
+                      <a:solidFill>
+                        <a:srgbClr val="EEF3F8"/>
+                      </a:solidFill>
+                      <a:prstDash val="solid"/>
+                      <a:round/>
+                      <a:headEnd type="none" w="med" len="med"/>
+                      <a:tailEnd type="none" w="med" len="med"/>
+                    </a:lnL>
+                    <a:lnR w="12700" cap="flat" cmpd="sng" algn="ctr">
+                      <a:solidFill>
+                        <a:srgbClr val="EEF3F8"/>
+                      </a:solidFill>
+                      <a:prstDash val="solid"/>
+                      <a:round/>
+                      <a:headEnd type="none" w="med" len="med"/>
+                      <a:tailEnd type="none" w="med" len="med"/>
+                    </a:lnR>
+                    <a:lnT w="12700" cap="flat" cmpd="sng" algn="ctr">
+                      <a:solidFill>
+                        <a:srgbClr val="EEF3F8"/>
+                      </a:solidFill>
+                      <a:prstDash val="solid"/>
+                      <a:round/>
+                      <a:headEnd type="none" w="med" len="med"/>
+                      <a:tailEnd type="none" w="med" len="med"/>
+                    </a:lnT>
+                    <a:lnB w="12700" cap="flat" cmpd="sng" algn="ctr">
+                      <a:solidFill>
+                        <a:srgbClr val="EEF3F8"/>
+                      </a:solidFill>
+                      <a:prstDash val="solid"/>
+                      <a:round/>
+                      <a:headEnd type="none" w="med" len="med"/>
+                      <a:tailEnd type="none" w="med" len="med"/>
+                    </a:lnB>
+                    <a:solidFill>
+                      <a:schemeClr val="bg1"/>
+                    </a:solidFill>
+                  </a:tcPr>
+                </a:tc>
+              </a:tr>
+              <a:tr h="713232">
+                <a:tc>
+                  <a:txBody>
+                    <a:bodyPr/>
+                    <a:lstStyle/>
+                    <a:p>
+                      <a:pPr indent="0" marL="0">
+                        <a:buNone/>
+                      </a:pPr>
+                      <a:r>
+                        <a:rPr lang="en-US" sz="1400" b="1" dirty="0">
+                          <a:solidFill>
+                            <a:schemeClr val="tx1"/>
+                          </a:solidFill>
+                          <a:latin typeface="Calibri" pitchFamily="34" charset="0"/>
+                          <a:ea typeface="Calibri" pitchFamily="34" charset="-122"/>
+                          <a:cs typeface="Calibri" pitchFamily="34" charset="-120"/>
+                        </a:rPr>
+                        <a:t>OE5</a:t>
+                      </a:r>
+                      <a:endParaRPr lang="en-US" sz="1400" dirty="0">
+                        <a:latin typeface="Calibri" charset="0"/>
+                        <a:ea typeface="Calibri" charset="0"/>
+                        <a:cs typeface="Calibri" charset="0"/>
+                      </a:endParaRPr>
+                    </a:p>
+                  </a:txBody>
+                  <a:tcPr marL="137160" marR="137160" marT="45720" marB="45720" anchor="ctr">
+                    <a:lnL w="12700" cap="flat" cmpd="sng" algn="ctr">
+                      <a:solidFill>
+                        <a:srgbClr val="EEF3F8"/>
+                      </a:solidFill>
+                      <a:prstDash val="solid"/>
+                      <a:round/>
+                      <a:headEnd type="none" w="med" len="med"/>
+                      <a:tailEnd type="none" w="med" len="med"/>
+                    </a:lnL>
+                    <a:lnR w="12700" cap="flat" cmpd="sng" algn="ctr">
+                      <a:solidFill>
+                        <a:srgbClr val="EEF3F8"/>
+                      </a:solidFill>
+                      <a:prstDash val="solid"/>
+                      <a:round/>
+                      <a:headEnd type="none" w="med" len="med"/>
+                      <a:tailEnd type="none" w="med" len="med"/>
+                    </a:lnR>
+                    <a:lnT w="12700" cap="flat" cmpd="sng" algn="ctr">
+                      <a:solidFill>
+                        <a:srgbClr val="EEF3F8"/>
+                      </a:solidFill>
+                      <a:prstDash val="solid"/>
+                      <a:round/>
+                      <a:headEnd type="none" w="med" len="med"/>
+                      <a:tailEnd type="none" w="med" len="med"/>
+                    </a:lnT>
+                    <a:lnB w="12700" cap="flat" cmpd="sng" algn="ctr">
+                      <a:solidFill>
+                        <a:srgbClr val="EEF3F8"/>
+                      </a:solidFill>
+                      <a:prstDash val="solid"/>
+                      <a:round/>
+                      <a:headEnd type="none" w="med" len="med"/>
+                      <a:tailEnd type="none" w="med" len="med"/>
+                    </a:lnB>
+                    <a:solidFill>
+                      <a:schemeClr val="bg1"/>
+                    </a:solidFill>
+                  </a:tcPr>
+                </a:tc>
+                <a:tc>
+                  <a:txBody>
+                    <a:bodyPr/>
+                    <a:lstStyle/>
+                    <a:p>
+                      <a:pPr indent="0" marL="0">
+                        <a:buNone/>
+                      </a:pPr>
+                      <a:r>
+                        <a:rPr lang="en-US" sz="1400" dirty="0">
+                          <a:solidFill>
+                            <a:schemeClr val="tx1"/>
+                          </a:solidFill>
+                          <a:latin typeface="Calibri" pitchFamily="34" charset="0"/>
+                          <a:ea typeface="Calibri" pitchFamily="34" charset="-122"/>
+                          <a:cs typeface="Calibri" pitchFamily="34" charset="-120"/>
+                        </a:rPr>
+                        <a:t>Razão ΔCTO ÷ Σ encargos e resultado por fonte</a:t>
+                      </a:r>
+                      <a:endParaRPr lang="en-US" sz="1400" dirty="0">
+                        <a:latin typeface="Calibri" charset="0"/>
+                        <a:ea typeface="Calibri" charset="0"/>
+                        <a:cs typeface="Calibri" charset="0"/>
+                      </a:endParaRPr>
+                    </a:p>
+                  </a:txBody>
+                  <a:tcPr marL="137160" marR="137160" marT="45720" marB="45720" anchor="ctr">
+                    <a:lnL w="12700" cap="flat" cmpd="sng" algn="ctr">
+                      <a:solidFill>
+                        <a:srgbClr val="EEF3F8"/>
+                      </a:solidFill>
+                      <a:prstDash val="solid"/>
+                      <a:round/>
+                      <a:headEnd type="none" w="med" len="med"/>
+                      <a:tailEnd type="none" w="med" len="med"/>
+                    </a:lnL>
+                    <a:lnR w="12700" cap="flat" cmpd="sng" algn="ctr">
+                      <a:solidFill>
+                        <a:srgbClr val="EEF3F8"/>
+                      </a:solidFill>
+                      <a:prstDash val="solid"/>
+                      <a:round/>
+                      <a:headEnd type="none" w="med" len="med"/>
+                      <a:tailEnd type="none" w="med" len="med"/>
+                    </a:lnR>
+                    <a:lnT w="12700" cap="flat" cmpd="sng" algn="ctr">
+                      <a:solidFill>
+                        <a:srgbClr val="EEF3F8"/>
+                      </a:solidFill>
+                      <a:prstDash val="solid"/>
+                      <a:round/>
+                      <a:headEnd type="none" w="med" len="med"/>
+                      <a:tailEnd type="none" w="med" len="med"/>
+                    </a:lnT>
+                    <a:lnB w="12700" cap="flat" cmpd="sng" algn="ctr">
+                      <a:solidFill>
+                        <a:srgbClr val="EEF3F8"/>
+                      </a:solidFill>
+                      <a:prstDash val="solid"/>
+                      <a:round/>
+                      <a:headEnd type="none" w="med" len="med"/>
+                      <a:tailEnd type="none" w="med" len="med"/>
+                    </a:lnB>
+                    <a:solidFill>
+                      <a:schemeClr val="bg1"/>
+                    </a:solidFill>
+                  </a:tcPr>
+                </a:tc>
+                <a:tc>
+                  <a:txBody>
+                    <a:bodyPr/>
+                    <a:lstStyle/>
+                    <a:p>
+                      <a:pPr indent="0" marL="0">
+                        <a:buNone/>
+                      </a:pPr>
+                      <a:r>
+                        <a:rPr lang="en-US" sz="1400" dirty="0">
+                          <a:solidFill>
+                            <a:schemeClr val="tx1"/>
+                          </a:solidFill>
+                          <a:latin typeface="Calibri" pitchFamily="34" charset="0"/>
+                          <a:ea typeface="Calibri" pitchFamily="34" charset="-122"/>
+                          <a:cs typeface="Calibri" pitchFamily="34" charset="-120"/>
+                        </a:rPr>
+                        <a:t>Razão e R$ milhões/ano</a:t>
+                      </a:r>
+                      <a:endParaRPr lang="en-US" sz="1400" dirty="0">
+                        <a:latin typeface="Calibri" charset="0"/>
+                        <a:ea typeface="Calibri" charset="0"/>
+                        <a:cs typeface="Calibri" charset="0"/>
+                      </a:endParaRPr>
+                    </a:p>
+                  </a:txBody>
+                  <a:tcPr marL="137160" marR="137160" marT="45720" marB="45720" anchor="ctr">
+                    <a:lnL w="12700" cap="flat" cmpd="sng" algn="ctr">
+                      <a:solidFill>
+                        <a:srgbClr val="EEF3F8"/>
+                      </a:solidFill>
+                      <a:prstDash val="solid"/>
+                      <a:round/>
+                      <a:headEnd type="none" w="med" len="med"/>
+                      <a:tailEnd type="none" w="med" len="med"/>
+                    </a:lnL>
+                    <a:lnR w="12700" cap="flat" cmpd="sng" algn="ctr">
+                      <a:solidFill>
+                        <a:srgbClr val="EEF3F8"/>
+                      </a:solidFill>
+                      <a:prstDash val="solid"/>
+                      <a:round/>
+                      <a:headEnd type="none" w="med" len="med"/>
+                      <a:tailEnd type="none" w="med" len="med"/>
+                    </a:lnR>
+                    <a:lnT w="12700" cap="flat" cmpd="sng" algn="ctr">
+                      <a:solidFill>
+                        <a:srgbClr val="EEF3F8"/>
+                      </a:solidFill>
+                      <a:prstDash val="solid"/>
+                      <a:round/>
+                      <a:headEnd type="none" w="med" len="med"/>
+                      <a:tailEnd type="none" w="med" len="med"/>
+                    </a:lnT>
+                    <a:lnB w="12700" cap="flat" cmpd="sng" algn="ctr">
+                      <a:solidFill>
+                        <a:srgbClr val="EEF3F8"/>
+                      </a:solidFill>
+                      <a:prstDash val="solid"/>
+                      <a:round/>
+                      <a:headEnd type="none" w="med" len="med"/>
+                      <a:tailEnd type="none" w="med" len="med"/>
+                    </a:lnB>
+                    <a:solidFill>
+                      <a:schemeClr val="bg1"/>
+                    </a:solidFill>
+                  </a:tcPr>
+                </a:tc>
+                <a:tc>
+                  <a:txBody>
+                    <a:bodyPr/>
+                    <a:lstStyle/>
+                    <a:p>
+                      <a:pPr indent="0" marL="0">
+                        <a:buNone/>
+                      </a:pPr>
+                      <a:r>
+                        <a:rPr lang="en-US" sz="1400" dirty="0">
+                          <a:solidFill>
+                            <a:schemeClr val="tx1"/>
+                          </a:solidFill>
+                          <a:latin typeface="Calibri" pitchFamily="34" charset="0"/>
+                          <a:ea typeface="Calibri" pitchFamily="34" charset="-122"/>
+                          <a:cs typeface="Calibri" pitchFamily="34" charset="-120"/>
+                        </a:rPr>
+                        <a:t>≥ 1 confirma H1; varia com a MMGD</a:t>
                       </a:r>
                       <a:endParaRPr lang="en-US" sz="1400" dirty="0">
                         <a:latin typeface="Calibri" charset="0"/>
@@ -5989,7 +5989,7 @@
                   <a:schemeClr val="tx2"/>
                 </a:solidFill>
               </a:rPr>
-              <a:t>Todas as variáveis vêm das simulações horárias, exceto os encargos (OE5), calculados a partir do custo das baterias e da regra de rateio.</a:t>
+              <a:t>Todas as variáveis vêm das simulações horárias, exceto os encargos (OE4), calculados a partir do custo das baterias e da regra de rateio.</a:t>
             </a:r>
             <a:endParaRPr lang="en-US" sz="1400" dirty="0"/>
           </a:p>
@@ -12608,7 +12608,7 @@
                 <a:ea typeface="Cambria" pitchFamily="34" charset="-122"/>
                 <a:cs typeface="Cambria" pitchFamily="34" charset="-120"/>
               </a:rPr>
-              <a:t>Avaliar se o ganho econômico sistêmico obtido com a redução do curtailment e do custo total de operação do SIN, após a inserção de baterias, é equivalente aos encargos pagos pelas demais fontes para sua implantação.</a:t>
+              <a:t>Verificar, por meio de simulações horárias do SIN sem e com baterias, se o ganho econômico com a redução do curtailment (menor custo total de operação) é equivalente aos encargos que as demais fontes pagarão pela implantação das baterias.</a:t>
             </a:r>
             <a:endParaRPr lang="en-US" sz="2200" dirty="0"/>
           </a:p>
@@ -12756,7 +12756,7 @@
                   <a:schemeClr val="bg1"/>
                 </a:solidFill>
               </a:rPr>
-              <a:t>Medir a variação do CTO e do curtailment do SIN e confrontá-la com os encargos por fonte.</a:t>
+              <a:t>Ganho sistêmico (redução do CTO) em confronto com os encargos pagos por cada fonte.</a:t>
             </a:r>
             <a:endParaRPr lang="en-US" sz="1400" dirty="0"/>
           </a:p>
@@ -12904,7 +12904,7 @@
                   <a:schemeClr val="bg1"/>
                 </a:solidFill>
               </a:rPr>
-              <a:t>Simulações horárias do SIN sem e com baterias (NE e SE, 4 h), em cenários crescentes de MMGD.</a:t>
+              <a:t>Simulações horárias do SIN sem e com baterias (NE e SE, 4 h), em níveis crescentes de MMGD.</a:t>
             </a:r>
             <a:endParaRPr lang="en-US" sz="1400" dirty="0"/>
           </a:p>
@@ -13052,7 +13052,7 @@
                   <a:schemeClr val="bg1"/>
                 </a:solidFill>
               </a:rPr>
-              <a:t>Subsidiar o debate sobre o rateio dos custos das baterias entre as fontes.</a:t>
+              <a:t>Dizer se as baterias se pagam e quais fontes ganham ou perdem, subsidiando o rateio dos custos.</a:t>
             </a:r>
             <a:endParaRPr lang="en-US" sz="1400" dirty="0"/>
           </a:p>
@@ -13129,12 +13129,12 @@
         </p:nvSpPr>
         <p:spPr>
           <a:xfrm>
-            <a:off x="548640" y="1417320"/>
-            <a:ext cx="11094415" cy="896112"/>
+            <a:off x="548640" y="1371600"/>
+            <a:ext cx="11094415" cy="822960"/>
           </a:xfrm>
           <a:prstGeom prst="roundRect">
             <a:avLst>
-              <a:gd name="adj" fmla="val 12245"/>
+              <a:gd name="adj" fmla="val 13333"/>
             </a:avLst>
           </a:prstGeom>
           <a:solidFill>
@@ -13156,7 +13156,7 @@
         </p:nvSpPr>
         <p:spPr>
           <a:xfrm>
-            <a:off x="731520" y="1591056"/>
+            <a:off x="731520" y="1508760"/>
             <a:ext cx="914400" cy="548640"/>
           </a:xfrm>
           <a:prstGeom prst="roundRect">
@@ -13183,7 +13183,7 @@
         </p:nvSpPr>
         <p:spPr>
           <a:xfrm>
-            <a:off x="731520" y="1591056"/>
+            <a:off x="731520" y="1508760"/>
             <a:ext cx="914400" cy="548640"/>
           </a:xfrm>
           <a:prstGeom prst="rect">
@@ -13222,8 +13222,8 @@
         </p:nvSpPr>
         <p:spPr>
           <a:xfrm>
-            <a:off x="1920240" y="1508760"/>
-            <a:ext cx="3566160" cy="713232"/>
+            <a:off x="1920240" y="1463040"/>
+            <a:ext cx="3383280" cy="640080"/>
           </a:xfrm>
           <a:prstGeom prst="rect">
             <a:avLst/>
@@ -13247,7 +13247,7 @@
                 <a:ea typeface="Cambria" pitchFamily="34" charset="-122"/>
                 <a:cs typeface="Cambria" pitchFamily="34" charset="-120"/>
               </a:rPr>
-              <a:t>Quantificar o curtailment</a:t>
+              <a:t>Quantificar a redução do curtailment</a:t>
             </a:r>
             <a:endParaRPr lang="en-US" sz="1800" dirty="0"/>
           </a:p>
@@ -13261,8 +13261,8 @@
         </p:nvSpPr>
         <p:spPr>
           <a:xfrm>
-            <a:off x="5577840" y="1490472"/>
-            <a:ext cx="5120640" cy="749808"/>
+            <a:off x="5715000" y="1444752"/>
+            <a:ext cx="5029200" cy="676656"/>
           </a:xfrm>
           <a:prstGeom prst="rect">
             <a:avLst/>
@@ -13283,7 +13283,7 @@
                   <a:schemeClr val="tx2"/>
                 </a:solidFill>
               </a:rPr>
-              <a:t>de eólicas, UFVs centralizadas e UHEs, antes e depois das baterias, em cada cenário de MMGD.</a:t>
+              <a:t>de eólicas, UFVs centralizadas e UHEs com baterias, em cada nível de MMGD.</a:t>
             </a:r>
             <a:endParaRPr lang="en-US" sz="1400" dirty="0"/>
           </a:p>
@@ -13291,7 +13291,7 @@
       </p:sp>
       <p:pic>
         <p:nvPicPr>
-          <p:cNvPr id="8" name="Image 0" descr="Quantificar o curtailment">    </p:cNvPr>
+          <p:cNvPr id="8" name="Image 0" descr="Quantificar a redução do curtailment">    </p:cNvPr>
           <p:cNvPicPr>
             <a:picLocks noChangeAspect="1"/>
           </p:cNvPicPr>
@@ -13305,7 +13305,7 @@
         </p:blipFill>
         <p:spPr>
           <a:xfrm>
-            <a:off x="10957255" y="1664208"/>
+            <a:off x="10957255" y="1577340"/>
             <a:ext cx="411480" cy="411480"/>
           </a:xfrm>
           <a:prstGeom prst="rect">
@@ -13321,12 +13321,12 @@
         </p:nvSpPr>
         <p:spPr>
           <a:xfrm>
-            <a:off x="548640" y="2441448"/>
-            <a:ext cx="11094415" cy="896112"/>
+            <a:off x="548640" y="2304288"/>
+            <a:ext cx="11094415" cy="822960"/>
           </a:xfrm>
           <a:prstGeom prst="roundRect">
             <a:avLst>
-              <a:gd name="adj" fmla="val 12245"/>
+              <a:gd name="adj" fmla="val 13333"/>
             </a:avLst>
           </a:prstGeom>
           <a:solidFill>
@@ -13348,7 +13348,7 @@
         </p:nvSpPr>
         <p:spPr>
           <a:xfrm>
-            <a:off x="731520" y="2615184"/>
+            <a:off x="731520" y="2441448"/>
             <a:ext cx="914400" cy="548640"/>
           </a:xfrm>
           <a:prstGeom prst="roundRect">
@@ -13375,7 +13375,7 @@
         </p:nvSpPr>
         <p:spPr>
           <a:xfrm>
-            <a:off x="731520" y="2615184"/>
+            <a:off x="731520" y="2441448"/>
             <a:ext cx="914400" cy="548640"/>
           </a:xfrm>
           <a:prstGeom prst="rect">
@@ -13414,8 +13414,8 @@
         </p:nvSpPr>
         <p:spPr>
           <a:xfrm>
-            <a:off x="1920240" y="2532888"/>
-            <a:ext cx="3566160" cy="713232"/>
+            <a:off x="1920240" y="2395728"/>
+            <a:ext cx="3383280" cy="640080"/>
           </a:xfrm>
           <a:prstGeom prst="rect">
             <a:avLst/>
@@ -13439,7 +13439,7 @@
                 <a:ea typeface="Cambria" pitchFamily="34" charset="-122"/>
                 <a:cs typeface="Cambria" pitchFamily="34" charset="-120"/>
               </a:rPr>
-              <a:t>Comparar o despacho por fonte</a:t>
+              <a:t>Analisar despacho e armazenamento</a:t>
             </a:r>
             <a:endParaRPr lang="en-US" sz="1800" dirty="0"/>
           </a:p>
@@ -13453,8 +13453,8 @@
         </p:nvSpPr>
         <p:spPr>
           <a:xfrm>
-            <a:off x="5577840" y="2514600"/>
-            <a:ext cx="5120640" cy="749808"/>
+            <a:off x="5715000" y="2377440"/>
+            <a:ext cx="5029200" cy="676656"/>
           </a:xfrm>
           <a:prstGeom prst="rect">
             <a:avLst/>
@@ -13475,7 +13475,7 @@
                   <a:schemeClr val="tx2"/>
                 </a:solidFill>
               </a:rPr>
-              <a:t>UHEs, UTEs, UFVs e eólicas: identificar quais fontes são beneficiadas e quais são deslocadas.</a:t>
+              <a:t>identificar fontes beneficiadas e deslocadas e se a energia armazenada nas UHEs aumenta.</a:t>
             </a:r>
             <a:endParaRPr lang="en-US" sz="1400" dirty="0"/>
           </a:p>
@@ -13483,7 +13483,7 @@
       </p:sp>
       <p:pic>
         <p:nvPicPr>
-          <p:cNvPr id="14" name="Image 1" descr="Comparar o despacho por fonte">    </p:cNvPr>
+          <p:cNvPr id="14" name="Image 1" descr="Analisar despacho e armazenamento">    </p:cNvPr>
           <p:cNvPicPr>
             <a:picLocks noChangeAspect="1"/>
           </p:cNvPicPr>
@@ -13497,7 +13497,7 @@
         </p:blipFill>
         <p:spPr>
           <a:xfrm>
-            <a:off x="10957255" y="2688336"/>
+            <a:off x="10957255" y="2510028"/>
             <a:ext cx="411480" cy="411480"/>
           </a:xfrm>
           <a:prstGeom prst="rect">
@@ -13513,12 +13513,12 @@
         </p:nvSpPr>
         <p:spPr>
           <a:xfrm>
-            <a:off x="548640" y="3465576"/>
-            <a:ext cx="11094415" cy="896112"/>
+            <a:off x="548640" y="3236976"/>
+            <a:ext cx="11094415" cy="822960"/>
           </a:xfrm>
           <a:prstGeom prst="roundRect">
             <a:avLst>
-              <a:gd name="adj" fmla="val 12245"/>
+              <a:gd name="adj" fmla="val 13333"/>
             </a:avLst>
           </a:prstGeom>
           <a:solidFill>
@@ -13540,7 +13540,7 @@
         </p:nvSpPr>
         <p:spPr>
           <a:xfrm>
-            <a:off x="731520" y="3639312"/>
+            <a:off x="731520" y="3374136"/>
             <a:ext cx="914400" cy="548640"/>
           </a:xfrm>
           <a:prstGeom prst="roundRect">
@@ -13567,7 +13567,7 @@
         </p:nvSpPr>
         <p:spPr>
           <a:xfrm>
-            <a:off x="731520" y="3639312"/>
+            <a:off x="731520" y="3374136"/>
             <a:ext cx="914400" cy="548640"/>
           </a:xfrm>
           <a:prstGeom prst="rect">
@@ -13606,8 +13606,8 @@
         </p:nvSpPr>
         <p:spPr>
           <a:xfrm>
-            <a:off x="1920240" y="3557016"/>
-            <a:ext cx="3566160" cy="713232"/>
+            <a:off x="1920240" y="3328416"/>
+            <a:ext cx="3383280" cy="640080"/>
           </a:xfrm>
           <a:prstGeom prst="rect">
             <a:avLst/>
@@ -13631,7 +13631,7 @@
                 <a:ea typeface="Cambria" pitchFamily="34" charset="-122"/>
                 <a:cs typeface="Cambria" pitchFamily="34" charset="-120"/>
               </a:rPr>
-              <a:t>Verificar o armazenamento das UHEs</a:t>
+              <a:t>Calcular o ganho sistêmico (ΔCTO)</a:t>
             </a:r>
             <a:endParaRPr lang="en-US" sz="1800" dirty="0"/>
           </a:p>
@@ -13645,8 +13645,8 @@
         </p:nvSpPr>
         <p:spPr>
           <a:xfrm>
-            <a:off x="5577840" y="3538728"/>
-            <a:ext cx="5120640" cy="749808"/>
+            <a:off x="5715000" y="3310128"/>
+            <a:ext cx="5029200" cy="676656"/>
           </a:xfrm>
           <a:prstGeom prst="rect">
             <a:avLst/>
@@ -13667,7 +13667,7 @@
                   <a:schemeClr val="tx2"/>
                 </a:solidFill>
               </a:rPr>
-              <a:t>avaliar se as baterias aumentam ou não a energia armazenada nos reservatórios.</a:t>
+              <a:t>variação do custo total de operação do SIN, sem e com baterias.</a:t>
             </a:r>
             <a:endParaRPr lang="en-US" sz="1400" dirty="0"/>
           </a:p>
@@ -13675,7 +13675,7 @@
       </p:sp>
       <p:pic>
         <p:nvPicPr>
-          <p:cNvPr id="20" name="Image 2" descr="Verificar o armazenamento das UHEs">    </p:cNvPr>
+          <p:cNvPr id="20" name="Image 2" descr="Calcular o ganho sistêmico (ΔCTO)">    </p:cNvPr>
           <p:cNvPicPr>
             <a:picLocks noChangeAspect="1"/>
           </p:cNvPicPr>
@@ -13689,7 +13689,7 @@
         </p:blipFill>
         <p:spPr>
           <a:xfrm>
-            <a:off x="10957255" y="3712464"/>
+            <a:off x="10957255" y="3442716"/>
             <a:ext cx="411480" cy="411480"/>
           </a:xfrm>
           <a:prstGeom prst="rect">
@@ -13705,12 +13705,12 @@
         </p:nvSpPr>
         <p:spPr>
           <a:xfrm>
-            <a:off x="548640" y="4489704"/>
-            <a:ext cx="11094415" cy="896112"/>
+            <a:off x="548640" y="4169664"/>
+            <a:ext cx="11094415" cy="822960"/>
           </a:xfrm>
           <a:prstGeom prst="roundRect">
             <a:avLst>
-              <a:gd name="adj" fmla="val 12245"/>
+              <a:gd name="adj" fmla="val 13333"/>
             </a:avLst>
           </a:prstGeom>
           <a:solidFill>
@@ -13732,7 +13732,7 @@
         </p:nvSpPr>
         <p:spPr>
           <a:xfrm>
-            <a:off x="731520" y="4663440"/>
+            <a:off x="731520" y="4306824"/>
             <a:ext cx="914400" cy="548640"/>
           </a:xfrm>
           <a:prstGeom prst="roundRect">
@@ -13759,7 +13759,7 @@
         </p:nvSpPr>
         <p:spPr>
           <a:xfrm>
-            <a:off x="731520" y="4663440"/>
+            <a:off x="731520" y="4306824"/>
             <a:ext cx="914400" cy="548640"/>
           </a:xfrm>
           <a:prstGeom prst="rect">
@@ -13798,8 +13798,8 @@
         </p:nvSpPr>
         <p:spPr>
           <a:xfrm>
-            <a:off x="1920240" y="4581144"/>
-            <a:ext cx="3566160" cy="713232"/>
+            <a:off x="1920240" y="4261104"/>
+            <a:ext cx="3383280" cy="640080"/>
           </a:xfrm>
           <a:prstGeom prst="rect">
             <a:avLst/>
@@ -13823,7 +13823,7 @@
                 <a:ea typeface="Cambria" pitchFamily="34" charset="-122"/>
                 <a:cs typeface="Cambria" pitchFamily="34" charset="-120"/>
               </a:rPr>
-              <a:t>Calcular a variação do CTO</a:t>
+              <a:t>Estimar os encargos por fonte</a:t>
             </a:r>
             <a:endParaRPr lang="en-US" sz="1800" dirty="0"/>
           </a:p>
@@ -13837,8 +13837,8 @@
         </p:nvSpPr>
         <p:spPr>
           <a:xfrm>
-            <a:off x="5577840" y="4562856"/>
-            <a:ext cx="5120640" cy="749808"/>
+            <a:off x="5715000" y="4242816"/>
+            <a:ext cx="5029200" cy="676656"/>
           </a:xfrm>
           <a:prstGeom prst="rect">
             <a:avLst/>
@@ -13859,7 +13859,7 @@
                   <a:schemeClr val="tx2"/>
                 </a:solidFill>
               </a:rPr>
-              <a:t>diferença do custo total de operação do SIN sem e com baterias.</a:t>
+              <a:t>valor a ser pago por UHEs, UTEs, eólicas e UFVs pela implantação das baterias.</a:t>
             </a:r>
             <a:endParaRPr lang="en-US" sz="1400" dirty="0"/>
           </a:p>
@@ -13867,7 +13867,7 @@
       </p:sp>
       <p:pic>
         <p:nvPicPr>
-          <p:cNvPr id="26" name="Image 3" descr="Calcular a variação do CTO">    </p:cNvPr>
+          <p:cNvPr id="26" name="Image 3" descr="Estimar os encargos por fonte">    </p:cNvPr>
           <p:cNvPicPr>
             <a:picLocks noChangeAspect="1"/>
           </p:cNvPicPr>
@@ -13881,7 +13881,7 @@
         </p:blipFill>
         <p:spPr>
           <a:xfrm>
-            <a:off x="10957255" y="4736592"/>
+            <a:off x="10957255" y="4375404"/>
             <a:ext cx="411480" cy="411480"/>
           </a:xfrm>
           <a:prstGeom prst="rect">
@@ -13897,12 +13897,12 @@
         </p:nvSpPr>
         <p:spPr>
           <a:xfrm>
-            <a:off x="548640" y="5513832"/>
-            <a:ext cx="11094415" cy="896112"/>
+            <a:off x="548640" y="5102352"/>
+            <a:ext cx="11094415" cy="822960"/>
           </a:xfrm>
           <a:prstGeom prst="roundRect">
             <a:avLst>
-              <a:gd name="adj" fmla="val 12245"/>
+              <a:gd name="adj" fmla="val 13333"/>
             </a:avLst>
           </a:prstGeom>
           <a:solidFill>
@@ -13924,7 +13924,7 @@
         </p:nvSpPr>
         <p:spPr>
           <a:xfrm>
-            <a:off x="731520" y="5687568"/>
+            <a:off x="731520" y="5239512"/>
             <a:ext cx="914400" cy="548640"/>
           </a:xfrm>
           <a:prstGeom prst="roundRect">
@@ -13951,7 +13951,7 @@
         </p:nvSpPr>
         <p:spPr>
           <a:xfrm>
-            <a:off x="731520" y="5687568"/>
+            <a:off x="731520" y="5239512"/>
             <a:ext cx="914400" cy="548640"/>
           </a:xfrm>
           <a:prstGeom prst="rect">
@@ -13990,8 +13990,8 @@
         </p:nvSpPr>
         <p:spPr>
           <a:xfrm>
-            <a:off x="1920240" y="5605272"/>
-            <a:ext cx="3566160" cy="713232"/>
+            <a:off x="1920240" y="5193792"/>
+            <a:ext cx="3383280" cy="640080"/>
           </a:xfrm>
           <a:prstGeom prst="rect">
             <a:avLst/>
@@ -14015,7 +14015,7 @@
                 <a:ea typeface="Cambria" pitchFamily="34" charset="-122"/>
                 <a:cs typeface="Cambria" pitchFamily="34" charset="-120"/>
               </a:rPr>
-              <a:t>Estimar os encargos por fonte</a:t>
+              <a:t>Comparar ganho e encargos</a:t>
             </a:r>
             <a:endParaRPr lang="en-US" sz="1800" dirty="0"/>
           </a:p>
@@ -14029,8 +14029,8 @@
         </p:nvSpPr>
         <p:spPr>
           <a:xfrm>
-            <a:off x="5577840" y="5586984"/>
-            <a:ext cx="5120640" cy="749808"/>
+            <a:off x="5715000" y="5175504"/>
+            <a:ext cx="5029200" cy="676656"/>
           </a:xfrm>
           <a:prstGeom prst="rect">
             <a:avLst/>
@@ -14051,7 +14051,7 @@
                   <a:schemeClr val="tx2"/>
                 </a:solidFill>
               </a:rPr>
-              <a:t>valor a ser pago por cada fonte pelas baterias e comparação com a variação do CTO.</a:t>
+              <a:t>no sistema e por fonte, testando H1 e a sensibilidade ao nível de MMGD.</a:t>
             </a:r>
             <a:endParaRPr lang="en-US" sz="1400" dirty="0"/>
           </a:p>
@@ -14059,7 +14059,7 @@
       </p:sp>
       <p:pic>
         <p:nvPicPr>
-          <p:cNvPr id="32" name="Image 4" descr="Estimar os encargos por fonte">    </p:cNvPr>
+          <p:cNvPr id="32" name="Image 4" descr="Comparar ganho e encargos">    </p:cNvPr>
           <p:cNvPicPr>
             <a:picLocks noChangeAspect="1"/>
           </p:cNvPicPr>
@@ -14073,7 +14073,7 @@
         </p:blipFill>
         <p:spPr>
           <a:xfrm>
-            <a:off x="10957255" y="5760720"/>
+            <a:off x="10957255" y="5308092"/>
             <a:ext cx="411480" cy="411480"/>
           </a:xfrm>
           <a:prstGeom prst="rect">
@@ -14081,6 +14081,42 @@
           </a:prstGeom>
         </p:spPr>
       </p:pic>
+      <p:sp>
+        <p:nvSpPr>
+          <p:cNvPr id="33" name="Text 26"/>
+          <p:cNvSpPr txBox="1"/>
+          <p:nvPr/>
+        </p:nvSpPr>
+        <p:spPr>
+          <a:xfrm>
+            <a:off x="548640" y="6053328"/>
+            <a:ext cx="10180015" cy="320040"/>
+          </a:xfrm>
+          <a:prstGeom prst="rect">
+            <a:avLst/>
+          </a:prstGeom>
+          <a:noFill/>
+          <a:ln/>
+        </p:spPr>
+        <p:txBody>
+          <a:bodyPr wrap="square" lIns="0" tIns="0" rIns="0" bIns="0" rtlCol="0" anchor="t"/>
+          <a:lstStyle/>
+          <a:p>
+            <a:pPr indent="0" marL="0">
+              <a:buNone/>
+            </a:pPr>
+            <a:r>
+              <a:rPr lang="en-US" sz="1400" b="1" dirty="0">
+                <a:solidFill>
+                  <a:schemeClr val="tx2"/>
+                </a:solidFill>
+              </a:rPr>
+              <a:t>OE1 a OE3 medem o ganho, OE4 mede o custo e OE5 responde à pergunta de pesquisa.</a:t>
+            </a:r>
+            <a:endParaRPr lang="en-US" sz="1400" dirty="0"/>
+          </a:p>
+        </p:txBody>
+      </p:sp>
       <p:sp>
         <p:nvSpPr>
           <p:cNvPr id="25" name="Slide Number Placeholder 0"/>

</xml_diff>

<commit_message>
Corrige slides de rateio: quatro patamares de flexibilidade e cenários por fonte
Co-Authored-By: Claude Sonnet 5.5 <noreply@anthropic.com>
Claude-Session: https://claude.ai/code/session_018oVMGfcbhG1itrwj795JhB
</commit_message>
<xml_diff>
--- a/Baterias_SIN_Economia_Setor_Eletrico_I.pptx
+++ b/Baterias_SIN_Economia_Setor_Eletrico_I.pptx
@@ -127,12 +127,12 @@
   <p:extLst>
     <p:ext uri="{521415D9-36F7-43E2-AB2F-B90AF26B5E84}">
       <p14:sectionLst xmlns:p14="http://schemas.microsoft.com/office/powerpoint/2010/main">
-        <p14:section name="Abertura" id="{9e83f80d-1974-442e-621d-9cfa1c0eb03a}">
+        <p14:section name="Abertura" id="{23f4813b-2755-baf6-a32e-c49f5618e714}">
           <p14:sldIdLst>
             <p14:sldId id="256"/>
           </p14:sldIdLst>
         </p14:section>
-        <p14:section name="Introdução" id="{976cb22c-1c3d-9128-d66e-a5be9b271e92}">
+        <p14:section name="Introdução" id="{cf785abe-d753-9661-bb6f-3668b2ebf8a0}">
           <p14:sldIdLst>
             <p14:sldId id="257"/>
             <p14:sldId id="258"/>
@@ -140,13 +140,13 @@
             <p14:sldId id="260"/>
           </p14:sldIdLst>
         </p14:section>
-        <p14:section name="Objetivos" id="{c6186bae-ee6a-4ca3-9c17-c4dc70eddbcc}">
+        <p14:section name="Objetivos" id="{4421d5ee-5c2a-bb44-8130-000d2b163357}">
           <p14:sldIdLst>
             <p14:sldId id="261"/>
             <p14:sldId id="262"/>
           </p14:sldIdLst>
         </p14:section>
-        <p14:section name="Método" id="{26493bf6-070c-154d-cb02-d0a5aeba2246}">
+        <p14:section name="Método" id="{3905fe6b-e4b0-57a4-bd21-2cecb074173b}">
           <p14:sldIdLst>
             <p14:sldId id="263"/>
             <p14:sldId id="264"/>
@@ -154,13 +154,13 @@
             <p14:sldId id="266"/>
           </p14:sldIdLst>
         </p14:section>
-        <p14:section name="Análise" id="{f783c7a7-d89f-e7c7-1169-8de2f534e1e7}">
+        <p14:section name="Análise" id="{ea4407cd-10a9-8af2-8d8d-2f8754b579db}">
           <p14:sldIdLst>
             <p14:sldId id="267"/>
             <p14:sldId id="268"/>
           </p14:sldIdLst>
         </p14:section>
-        <p14:section name="Encargos e benefícios" id="{064a48ef-eaac-293f-da8d-524665e1eaf9}">
+        <p14:section name="Encargos e benefícios" id="{5ce16659-72c5-4beb-998b-e92bd871b8ad}">
           <p14:sldIdLst>
             <p14:sldId id="269"/>
             <p14:sldId id="270"/>
@@ -170,7 +170,7 @@
             <p14:sldId id="274"/>
           </p14:sldIdLst>
         </p14:section>
-        <p14:section name="Fechamento" id="{a8e2627d-1f9e-b4db-ad49-e8edfa0436c7}">
+        <p14:section name="Fechamento" id="{c211a574-f213-3be3-17c1-128c828bd6f1}">
           <p14:sldIdLst>
             <p14:sldId id="275"/>
             <p14:sldId id="276"/>
@@ -235,7 +235,7 @@
               <c:strCache>
                 <c:ptCount val="1"/>
                 <c:pt idx="0">
-                  <c:v>R1: rateio universal</c:v>
+                  <c:v>A: hidro e térmicas em P1</c:v>
                 </c:pt>
               </c:strCache>
             </c:strRef>
@@ -318,7 +318,7 @@
               <c:strCache>
                 <c:ptCount val="1"/>
                 <c:pt idx="0">
-                  <c:v>R2: modulado por flexibilidade</c:v>
+                  <c:v>B: distribuídas entre P1 e P4</c:v>
                 </c:pt>
               </c:strCache>
             </c:strRef>
@@ -380,13 +380,96 @@
                 <c:formatCode>General</c:formatCode>
                 <c:ptCount val="3"/>
                 <c:pt idx="0">
-                  <c:v>24.4</c:v>
+                  <c:v>44.6</c:v>
                 </c:pt>
                 <c:pt idx="1">
-                  <c:v>49.8</c:v>
+                  <c:v>36.5</c:v>
                 </c:pt>
                 <c:pt idx="2">
-                  <c:v>25.8</c:v>
+                  <c:v>18.9</c:v>
+                </c:pt>
+              </c:numCache>
+            </c:numRef>
+          </c:val>
+        </c:ser>
+        <c:ser>
+          <c:idx val="2"/>
+          <c:order val="2"/>
+          <c:tx>
+            <c:strRef>
+              <c:f>Sheet1!$D$1</c:f>
+              <c:strCache>
+                <c:ptCount val="1"/>
+                <c:pt idx="0">
+                  <c:v>C: hidro e térmicas em P4</c:v>
+                </c:pt>
+              </c:strCache>
+            </c:strRef>
+          </c:tx>
+          <c:spPr>
+            <a:solidFill>
+              <a:srgbClr val="1FB5A8"/>
+            </a:solidFill>
+            <a:effectLst/>
+          </c:spPr>
+          <c:invertIfNegative val="0"/>
+          <c:dLbls>
+            <c:numFmt formatCode="0.0" sourceLinked="0"/>
+            <c:txPr>
+              <a:bodyPr/>
+              <a:lstStyle/>
+              <a:p>
+                <a:pPr>
+                  <a:defRPr b="0" i="0" strike="noStrike" sz="1200" u="none">
+                    <a:solidFill>
+                      <a:srgbClr val="0B1A2E"/>
+                    </a:solidFill>
+                    <a:latin typeface="+mn-lt"/>
+                  </a:defRPr>
+                </a:pPr>
+              </a:p>
+            </c:txPr>
+            <c:showLegendKey val="0"/>
+            <c:showVal val="1"/>
+            <c:showCatName val="0"/>
+            <c:showSerName val="0"/>
+            <c:showPercent val="0"/>
+            <c:showBubbleSize val="0"/>
+            <c:showLeaderLines val="0"/>
+          </c:dLbls>
+          <c:cat>
+            <c:multiLvlStrRef>
+              <c:f>Sheet1!$A$2:$A$4</c:f>
+              <c:multiLvlStrCache>
+                <c:ptCount val="3"/>
+                <c:lvl>
+                  <c:pt idx="0">
+                    <c:v>Hidrelétricas</c:v>
+                  </c:pt>
+                  <c:pt idx="1">
+                    <c:v>Eólicas e solares</c:v>
+                  </c:pt>
+                  <c:pt idx="2">
+                    <c:v>Térmicas e demais</c:v>
+                  </c:pt>
+                </c:lvl>
+              </c:multiLvlStrCache>
+            </c:multiLvlStrRef>
+          </c:cat>
+          <c:val>
+            <c:numRef>
+              <c:f>Sheet1!$D$2:$D$4</c:f>
+              <c:numCache>
+                <c:formatCode>General</c:formatCode>
+                <c:ptCount val="3"/>
+                <c:pt idx="0">
+                  <c:v>28.9</c:v>
+                </c:pt>
+                <c:pt idx="1">
+                  <c:v>58.9</c:v>
+                </c:pt>
+                <c:pt idx="2">
+                  <c:v>12.2</c:v>
                 </c:pt>
               </c:numCache>
             </c:numRef>
@@ -416,7 +499,7 @@
           <c:showBubbleSize val="0"/>
           <c:showLeaderLines val="0"/>
         </c:dLbls>
-        <c:gapWidth val="50"/>
+        <c:gapWidth val="40"/>
         <c:overlap val="0"/>
         <c:axId val="2094734554"/>
         <c:axId val="2094734552"/>
@@ -1841,7 +1924,7 @@
           <a:p>
             <a:r>
               <a:rPr lang="en-US" dirty="0"/>
-              <a:t>Os coeficientes de 100% a 25% são da proposta da área técnica em consulta pública; podem mudar. Os três cenários de rateio (R1 a R3) alimentam a análise de sensibilidade do OE4 e do OE5.</a:t>
+              <a:t>Os quatro patamares (100%, 75%, 50% e 25%) são da proposta da área técnica em consulta pública; podem mudar. Segundo resumos da nota técnica, valem para todas as classes de geração, e eólicas e solares entram inicialmente no P1. Os critérios de cada patamar não foram localizados. Os cenários de rateio R1 a R3 alimentam a análise de sensibilidade do OE4 e do OE5.</a:t>
             </a:r>
             <a:endParaRPr lang="en-US" dirty="0"/>
           </a:p>
@@ -1929,7 +2012,7 @@
           <a:p>
             <a:r>
               <a:rPr lang="en-US" dirty="0"/>
-              <a:t>Exercício ilustrativo, não é a regra oficial. Parcela da fonte = geração x coeficiente, dividida pela soma. R1 não usa coeficiente. Em R2, hidro 25% e eólica e solar 100% são as pontas citadas na proposta; as térmicas variam de 25% a 100% e o gráfico usa o ponto médio. Resultado do ponto médio: hidro 24,4%, eólica e solar 49,8%, térmicas 25,8%. Faixas: térmicas a 100% dá hidro 21,1%, eólica e solar 43,1%, térmicas 35,8%; térmicas a 25% dá 28,9%, 58,9% e 12,2%. A MMGD está fora do rateio e a amostra da EPE pode incluí-la na geração.</a:t>
+              <a:t>Exercício ilustrativo, não é a regra oficial. Parcela da fonte = geração x coeficiente, dividida pela soma dos pesos. Eólicas e solares ficam em P1 (100%), como na proposta. Hidrelétricas e térmicas recebem o mesmo coeficiente k em cada cenário. A: k = 100% (todas em P1), que equivale ao rateio universal sem diferenciar: 51,7%, 26,4% e 21,9%. B: k = 62,5%, média simples dos quatro patamares (1 + 0,75 + 0,5 + 0,25, dividido por 4), equivalente a distribuição uniforme: pesos 32,31, 26,40 e 13,69, soma 72,4, parcelas 44,6%, 36,5% e 18,9%. C: k = 25% (todas em P4): pesos 12,93, 26,40 e 5,48, soma 44,8, parcelas 28,9%, 58,9% e 12,2%. Limitações: os critérios de cada patamar e a classificação das usinas não foram localizados; hidro e térmicas têm distribuições diferentes na prática; 'térmicas e demais' é um resíduo e pode incluir MMGD, que está fora do rateio.</a:t>
             </a:r>
             <a:endParaRPr lang="en-US" dirty="0"/>
           </a:p>
@@ -2105,7 +2188,7 @@
           <a:p>
             <a:r>
               <a:rPr lang="en-US" dirty="0"/>
-              <a:t>Esta tabela organiza as hipóteses: eólicas e UFVs pagam mais, mas são as que mais ganham com menos corte. As térmicas podem perder despacho. As hidrelétricas pagam menos e ganham em risco hidrológico e armazenamento. As simulações dirão o saldo real.</a:t>
+              <a:t>Esta tabela organiza as hipóteses: eólicas e UFVs partem do patamar mais alto, mas são as que mais ganham com menos corte. As térmicas podem perder despacho. As hidrelétricas dependem do patamar em que forem classificadas e ganham em risco hidrológico e armazenamento. As simulações dirão o saldo real.</a:t>
             </a:r>
             <a:endParaRPr lang="en-US" dirty="0"/>
           </a:p>
@@ -11718,7 +11801,7 @@
                   <a:schemeClr val="tx1"/>
                 </a:solidFill>
               </a:rPr>
-              <a:t>Proposta da área técnica da ANEEL (NT 101/2026): quanto menos flexível a fonte, maior a parcela</a:t>
+              <a:t>Proposta da área técnica da ANEEL (NT 101/2026): quanto menos flexível a usina, maior a parcela</a:t>
             </a:r>
             <a:endParaRPr lang="en-US" sz="1600" dirty="0"/>
           </a:p>
@@ -11732,8 +11815,8 @@
         </p:nvSpPr>
         <p:spPr>
           <a:xfrm>
-            <a:off x="548640" y="2194560"/>
-            <a:ext cx="6126480" cy="320040"/>
+            <a:off x="548640" y="2011680"/>
+            <a:ext cx="6126480" cy="274320"/>
           </a:xfrm>
           <a:prstGeom prst="rect">
             <a:avLst/>
@@ -11754,7 +11837,7 @@
                   <a:schemeClr val="tx2"/>
                 </a:solidFill>
               </a:rPr>
-              <a:t>Inflexíveis e intermitentes</a:t>
+              <a:t>P1: inflexível</a:t>
             </a:r>
             <a:endParaRPr lang="en-US" sz="1400" dirty="0"/>
           </a:p>
@@ -11762,18 +11845,18 @@
       </p:sp>
       <p:sp>
         <p:nvSpPr>
-          <p:cNvPr id="5" name="Share bar 1"/>
+          <p:cNvPr id="5" name="Tier bar 1"/>
           <p:cNvSpPr/>
           <p:nvPr/>
         </p:nvSpPr>
         <p:spPr>
           <a:xfrm>
-            <a:off x="548640" y="2560320"/>
-            <a:ext cx="6126480" cy="457200"/>
+            <a:off x="548640" y="2304288"/>
+            <a:ext cx="6126480" cy="384048"/>
           </a:xfrm>
           <a:prstGeom prst="roundRect">
             <a:avLst>
-              <a:gd name="adj" fmla="val 16000"/>
+              <a:gd name="adj" fmla="val 19048"/>
             </a:avLst>
           </a:prstGeom>
           <a:solidFill>
@@ -11795,8 +11878,8 @@
         </p:nvSpPr>
         <p:spPr>
           <a:xfrm>
-            <a:off x="685800" y="2560320"/>
-            <a:ext cx="2743200" cy="457200"/>
+            <a:off x="685800" y="2304288"/>
+            <a:ext cx="2743200" cy="384048"/>
           </a:xfrm>
           <a:prstGeom prst="rect">
             <a:avLst/>
@@ -11831,8 +11914,8 @@
         </p:nvSpPr>
         <p:spPr>
           <a:xfrm>
-            <a:off x="548640" y="3154680"/>
-            <a:ext cx="6126480" cy="320040"/>
+            <a:off x="548640" y="2788920"/>
+            <a:ext cx="6126480" cy="274320"/>
           </a:xfrm>
           <a:prstGeom prst="rect">
             <a:avLst/>
@@ -11853,7 +11936,7 @@
                   <a:schemeClr val="tx2"/>
                 </a:solidFill>
               </a:rPr>
-              <a:t>Flexibilidade intermediária</a:t>
+              <a:t>P2: baixa flexibilidade</a:t>
             </a:r>
             <a:endParaRPr lang="en-US" sz="1400" dirty="0"/>
           </a:p>
@@ -11861,18 +11944,18 @@
       </p:sp>
       <p:sp>
         <p:nvSpPr>
-          <p:cNvPr id="8" name="Share bar 2"/>
+          <p:cNvPr id="8" name="Tier bar 2"/>
           <p:cNvSpPr/>
           <p:nvPr/>
         </p:nvSpPr>
         <p:spPr>
           <a:xfrm>
-            <a:off x="548640" y="3520440"/>
-            <a:ext cx="3063240" cy="457200"/>
+            <a:off x="548640" y="3081528"/>
+            <a:ext cx="4594860" cy="384048"/>
           </a:xfrm>
           <a:prstGeom prst="roundRect">
             <a:avLst>
-              <a:gd name="adj" fmla="val 16000"/>
+              <a:gd name="adj" fmla="val 19048"/>
             </a:avLst>
           </a:prstGeom>
           <a:solidFill>
@@ -11894,8 +11977,8 @@
         </p:nvSpPr>
         <p:spPr>
           <a:xfrm>
-            <a:off x="685800" y="3520440"/>
-            <a:ext cx="2743200" cy="457200"/>
+            <a:off x="685800" y="3081528"/>
+            <a:ext cx="2743200" cy="384048"/>
           </a:xfrm>
           <a:prstGeom prst="rect">
             <a:avLst/>
@@ -11916,7 +11999,7 @@
                   <a:schemeClr val="tx1"/>
                 </a:solidFill>
               </a:rPr>
-              <a:t>75% a 25%</a:t>
+              <a:t>75%</a:t>
             </a:r>
             <a:endParaRPr lang="en-US" sz="1600" dirty="0"/>
           </a:p>
@@ -11930,8 +12013,8 @@
         </p:nvSpPr>
         <p:spPr>
           <a:xfrm>
-            <a:off x="548640" y="4114800"/>
-            <a:ext cx="6126480" cy="320040"/>
+            <a:off x="548640" y="3566160"/>
+            <a:ext cx="6126480" cy="274320"/>
           </a:xfrm>
           <a:prstGeom prst="rect">
             <a:avLst/>
@@ -11952,7 +12035,7 @@
                   <a:schemeClr val="tx2"/>
                 </a:solidFill>
               </a:rPr>
-              <a:t>Flexibilidade muito alta</a:t>
+              <a:t>P3: alta flexibilidade</a:t>
             </a:r>
             <a:endParaRPr lang="en-US" sz="1400" dirty="0"/>
           </a:p>
@@ -11960,18 +12043,117 @@
       </p:sp>
       <p:sp>
         <p:nvSpPr>
-          <p:cNvPr id="11" name="Share bar 3"/>
+          <p:cNvPr id="11" name="Tier bar 3"/>
           <p:cNvSpPr/>
           <p:nvPr/>
         </p:nvSpPr>
         <p:spPr>
           <a:xfrm>
-            <a:off x="548640" y="4480560"/>
-            <a:ext cx="1531620" cy="457200"/>
+            <a:off x="548640" y="3858768"/>
+            <a:ext cx="3063240" cy="384048"/>
           </a:xfrm>
           <a:prstGeom prst="roundRect">
             <a:avLst>
-              <a:gd name="adj" fmla="val 16000"/>
+              <a:gd name="adj" fmla="val 19048"/>
+            </a:avLst>
+          </a:prstGeom>
+          <a:solidFill>
+            <a:schemeClr val="accent1"/>
+          </a:solidFill>
+          <a:ln w="12700">
+            <a:solidFill>
+              <a:schemeClr val="accent1"/>
+            </a:solidFill>
+            <a:prstDash val="solid"/>
+          </a:ln>
+        </p:spPr>
+      </p:sp>
+      <p:sp>
+        <p:nvSpPr>
+          <p:cNvPr id="12" name="Text 10"/>
+          <p:cNvSpPr txBox="1"/>
+          <p:nvPr/>
+        </p:nvSpPr>
+        <p:spPr>
+          <a:xfrm>
+            <a:off x="685800" y="3858768"/>
+            <a:ext cx="2743200" cy="384048"/>
+          </a:xfrm>
+          <a:prstGeom prst="rect">
+            <a:avLst/>
+          </a:prstGeom>
+          <a:noFill/>
+          <a:ln/>
+        </p:spPr>
+        <p:txBody>
+          <a:bodyPr wrap="square" lIns="0" tIns="0" rIns="0" bIns="0" rtlCol="0" anchor="ctr"/>
+          <a:lstStyle/>
+          <a:p>
+            <a:pPr indent="0" marL="0">
+              <a:buNone/>
+            </a:pPr>
+            <a:r>
+              <a:rPr lang="en-US" sz="1600" b="1" dirty="0">
+                <a:solidFill>
+                  <a:schemeClr val="tx1"/>
+                </a:solidFill>
+              </a:rPr>
+              <a:t>50%</a:t>
+            </a:r>
+            <a:endParaRPr lang="en-US" sz="1600" dirty="0"/>
+          </a:p>
+        </p:txBody>
+      </p:sp>
+      <p:sp>
+        <p:nvSpPr>
+          <p:cNvPr id="13" name="Text 11"/>
+          <p:cNvSpPr txBox="1"/>
+          <p:nvPr/>
+        </p:nvSpPr>
+        <p:spPr>
+          <a:xfrm>
+            <a:off x="548640" y="4343400"/>
+            <a:ext cx="6126480" cy="274320"/>
+          </a:xfrm>
+          <a:prstGeom prst="rect">
+            <a:avLst/>
+          </a:prstGeom>
+          <a:noFill/>
+          <a:ln/>
+        </p:spPr>
+        <p:txBody>
+          <a:bodyPr wrap="square" lIns="0" tIns="0" rIns="0" bIns="0" rtlCol="0" anchor="t"/>
+          <a:lstStyle/>
+          <a:p>
+            <a:pPr indent="0" marL="0">
+              <a:buNone/>
+            </a:pPr>
+            <a:r>
+              <a:rPr lang="en-US" sz="1400" dirty="0">
+                <a:solidFill>
+                  <a:schemeClr val="tx2"/>
+                </a:solidFill>
+              </a:rPr>
+              <a:t>P4: flexibilidade muito alta</a:t>
+            </a:r>
+            <a:endParaRPr lang="en-US" sz="1400" dirty="0"/>
+          </a:p>
+        </p:txBody>
+      </p:sp>
+      <p:sp>
+        <p:nvSpPr>
+          <p:cNvPr id="14" name="Tier bar 4"/>
+          <p:cNvSpPr/>
+          <p:nvPr/>
+        </p:nvSpPr>
+        <p:spPr>
+          <a:xfrm>
+            <a:off x="548640" y="4636008"/>
+            <a:ext cx="1531620" cy="384048"/>
+          </a:xfrm>
+          <a:prstGeom prst="roundRect">
+            <a:avLst>
+              <a:gd name="adj" fmla="val 19048"/>
             </a:avLst>
           </a:prstGeom>
           <a:solidFill>
@@ -11987,14 +12169,14 @@
       </p:sp>
       <p:sp>
         <p:nvSpPr>
-          <p:cNvPr id="12" name="Text 10"/>
+          <p:cNvPr id="15" name="Text 13"/>
           <p:cNvSpPr txBox="1"/>
           <p:nvPr/>
         </p:nvSpPr>
         <p:spPr>
           <a:xfrm>
-            <a:off x="685800" y="4480560"/>
-            <a:ext cx="2743200" cy="457200"/>
+            <a:off x="685800" y="4636008"/>
+            <a:ext cx="2743200" cy="384048"/>
           </a:xfrm>
           <a:prstGeom prst="rect">
             <a:avLst/>
@@ -12023,14 +12205,14 @@
       </p:sp>
       <p:sp>
         <p:nvSpPr>
-          <p:cNvPr id="13" name="Text 11"/>
+          <p:cNvPr id="16" name="Text 14"/>
           <p:cNvSpPr txBox="1"/>
           <p:nvPr/>
         </p:nvSpPr>
         <p:spPr>
           <a:xfrm>
-            <a:off x="548640" y="5120640"/>
-            <a:ext cx="6126480" cy="914400"/>
+            <a:off x="548640" y="5212080"/>
+            <a:ext cx="6126480" cy="1005840"/>
           </a:xfrm>
           <a:prstGeom prst="rect">
             <a:avLst/>
@@ -12051,7 +12233,7 @@
                   <a:schemeClr val="tx2"/>
                 </a:solidFill>
               </a:rPr>
-              <a:t>Na prática: eólicas, UFVs e nucleares pagam mais, as térmicas um pouco menos e as hidrelétricas o menor patamar. A MMGD ficaria fora do rateio.</a:t>
+              <a:t>Os patamares valem para todas as classes de geração: o P4 é o mais flexível dentro de cada classe. Eólicas e solares partem do P1, sem armazenamento associado. Hidrelétricas e térmicas dependem da classificação anual do ONS.</a:t>
             </a:r>
             <a:endParaRPr lang="en-US" sz="1400" dirty="0"/>
           </a:p>
@@ -12059,7 +12241,7 @@
       </p:sp>
       <p:sp>
         <p:nvSpPr>
-          <p:cNvPr id="14" name="Text 12"/>
+          <p:cNvPr id="17" name="Text 15"/>
           <p:cNvSpPr txBox="1"/>
           <p:nvPr/>
         </p:nvSpPr>
@@ -12095,7 +12277,7 @@
       </p:sp>
       <p:sp>
         <p:nvSpPr>
-          <p:cNvPr id="15" name="Rateio scenario R1"/>
+          <p:cNvPr id="18" name="Rateio scenario R1"/>
           <p:cNvSpPr/>
           <p:nvPr/>
         </p:nvSpPr>
@@ -12122,7 +12304,7 @@
       </p:sp>
       <p:sp>
         <p:nvSpPr>
-          <p:cNvPr id="16" name="Scenario tag R1"/>
+          <p:cNvPr id="19" name="Scenario tag R1"/>
           <p:cNvSpPr/>
           <p:nvPr/>
         </p:nvSpPr>
@@ -12149,7 +12331,7 @@
       </p:sp>
       <p:sp>
         <p:nvSpPr>
-          <p:cNvPr id="17" name="Text 15"/>
+          <p:cNvPr id="20" name="Text 18"/>
           <p:cNvSpPr txBox="1"/>
           <p:nvPr/>
         </p:nvSpPr>
@@ -12188,7 +12370,7 @@
       </p:sp>
       <p:sp>
         <p:nvSpPr>
-          <p:cNvPr id="18" name="Text 16"/>
+          <p:cNvPr id="21" name="Text 19"/>
           <p:cNvSpPr txBox="1"/>
           <p:nvPr/>
         </p:nvSpPr>
@@ -12227,7 +12409,7 @@
       </p:sp>
       <p:sp>
         <p:nvSpPr>
-          <p:cNvPr id="19" name="Text 17"/>
+          <p:cNvPr id="22" name="Text 20"/>
           <p:cNvSpPr txBox="1"/>
           <p:nvPr/>
         </p:nvSpPr>
@@ -12263,7 +12445,7 @@
       </p:sp>
       <p:sp>
         <p:nvSpPr>
-          <p:cNvPr id="20" name="Rateio scenario R2"/>
+          <p:cNvPr id="23" name="Rateio scenario R2"/>
           <p:cNvSpPr/>
           <p:nvPr/>
         </p:nvSpPr>
@@ -12290,7 +12472,7 @@
       </p:sp>
       <p:sp>
         <p:nvSpPr>
-          <p:cNvPr id="21" name="Scenario tag R2"/>
+          <p:cNvPr id="24" name="Scenario tag R2"/>
           <p:cNvSpPr/>
           <p:nvPr/>
         </p:nvSpPr>
@@ -12317,7 +12499,7 @@
       </p:sp>
       <p:sp>
         <p:nvSpPr>
-          <p:cNvPr id="22" name="Text 20"/>
+          <p:cNvPr id="25" name="Text 23"/>
           <p:cNvSpPr txBox="1"/>
           <p:nvPr/>
         </p:nvSpPr>
@@ -12356,7 +12538,7 @@
       </p:sp>
       <p:sp>
         <p:nvSpPr>
-          <p:cNvPr id="23" name="Text 21"/>
+          <p:cNvPr id="26" name="Text 24"/>
           <p:cNvSpPr txBox="1"/>
           <p:nvPr/>
         </p:nvSpPr>
@@ -12395,7 +12577,7 @@
       </p:sp>
       <p:sp>
         <p:nvSpPr>
-          <p:cNvPr id="24" name="Text 22"/>
+          <p:cNvPr id="27" name="Text 25"/>
           <p:cNvSpPr txBox="1"/>
           <p:nvPr/>
         </p:nvSpPr>
@@ -12423,7 +12605,7 @@
                   <a:schemeClr val="tx2"/>
                 </a:solidFill>
               </a:rPr>
-              <a:t>Proposta da ANEEL em consulta: coeficientes de 100% a 25%.</a:t>
+              <a:t>Proposta da ANEEL em consulta: quatro patamares, de 100% a 25%.</a:t>
             </a:r>
             <a:endParaRPr lang="en-US" sz="1400" dirty="0"/>
           </a:p>
@@ -12431,7 +12613,7 @@
       </p:sp>
       <p:sp>
         <p:nvSpPr>
-          <p:cNvPr id="25" name="Rateio scenario R3"/>
+          <p:cNvPr id="28" name="Rateio scenario R3"/>
           <p:cNvSpPr/>
           <p:nvPr/>
         </p:nvSpPr>
@@ -12458,7 +12640,7 @@
       </p:sp>
       <p:sp>
         <p:nvSpPr>
-          <p:cNvPr id="26" name="Scenario tag R3"/>
+          <p:cNvPr id="29" name="Scenario tag R3"/>
           <p:cNvSpPr/>
           <p:nvPr/>
         </p:nvSpPr>
@@ -12485,7 +12667,7 @@
       </p:sp>
       <p:sp>
         <p:nvSpPr>
-          <p:cNvPr id="27" name="Text 25"/>
+          <p:cNvPr id="30" name="Text 28"/>
           <p:cNvSpPr txBox="1"/>
           <p:nvPr/>
         </p:nvSpPr>
@@ -12524,7 +12706,7 @@
       </p:sp>
       <p:sp>
         <p:nvSpPr>
-          <p:cNvPr id="28" name="Text 26"/>
+          <p:cNvPr id="31" name="Text 29"/>
           <p:cNvSpPr txBox="1"/>
           <p:nvPr/>
         </p:nvSpPr>
@@ -12563,7 +12745,7 @@
       </p:sp>
       <p:sp>
         <p:nvSpPr>
-          <p:cNvPr id="29" name="Text 27"/>
+          <p:cNvPr id="32" name="Text 30"/>
           <p:cNvSpPr txBox="1"/>
           <p:nvPr/>
         </p:nvSpPr>
@@ -12599,7 +12781,7 @@
       </p:sp>
       <p:sp>
         <p:nvSpPr>
-          <p:cNvPr id="30" name="Text 28"/>
+          <p:cNvPr id="33" name="Text 31"/>
           <p:cNvSpPr txBox="1"/>
           <p:nvPr/>
         </p:nvSpPr>
@@ -12635,7 +12817,7 @@
       </p:sp>
       <p:sp>
         <p:nvSpPr>
-          <p:cNvPr id="31" name="Text 29"/>
+          <p:cNvPr id="34" name="Text 32"/>
           <p:cNvSpPr txBox="1"/>
           <p:nvPr/>
         </p:nvSpPr>
@@ -12663,7 +12845,7 @@
                   <a:schemeClr val="tx2"/>
                 </a:solidFill>
               </a:rPr>
-              <a:t>Fontes: Agência iNFRA (6/10/2026); TAGD Law (2026); Canal Energia (2026); ANEEL, CP 37/2026. A fórmula final ainda será definida pela ANEEL.</a:t>
+              <a:t>Fontes: NT 101/2026 e CP 37/2026 (ANEEL), via Canal Solar, ePowerBay e TAGD Law (2026); Canal Energia (2026). A fórmula final ainda será definida pela ANEEL.</a:t>
             </a:r>
             <a:endParaRPr lang="en-US" sz="1000" dirty="0"/>
           </a:p>
@@ -12843,10 +13025,10 @@
             <a:tbl>
               <a:tblPr/>
               <a:tblGrid>
-                <a:gridCol w="1280160"/>
-                <a:gridCol w="640080"/>
+                <a:gridCol w="1463040"/>
                 <a:gridCol w="1051560"/>
-                <a:gridCol w="1764792"/>
+                <a:gridCol w="1097280"/>
+                <a:gridCol w="1124712"/>
               </a:tblGrid>
               <a:tr h="548640">
                 <a:tc>
@@ -12934,7 +13116,7 @@
                           <a:ea typeface="Calibri" pitchFamily="34" charset="-122"/>
                           <a:cs typeface="Calibri" pitchFamily="34" charset="-120"/>
                         </a:rPr>
-                        <a:t>R1</a:t>
+                        <a:t>A (k = 100%)</a:t>
                       </a:r>
                       <a:endParaRPr lang="en-US" sz="1400" dirty="0">
                         <a:latin typeface="Calibri" charset="0"/>
@@ -13002,7 +13184,7 @@
                           <a:ea typeface="Calibri" pitchFamily="34" charset="-122"/>
                           <a:cs typeface="Calibri" pitchFamily="34" charset="-120"/>
                         </a:rPr>
-                        <a:t>R2 (faixa)</a:t>
+                        <a:t>B (k = 62,5%)</a:t>
                       </a:r>
                       <a:endParaRPr lang="en-US" sz="1400" dirty="0">
                         <a:latin typeface="Calibri" charset="0"/>
@@ -13070,7 +13252,7 @@
                           <a:ea typeface="Calibri" pitchFamily="34" charset="-122"/>
                           <a:cs typeface="Calibri" pitchFamily="34" charset="-120"/>
                         </a:rPr>
-                        <a:t>R$ mi / R$ 1 bi</a:t>
+                        <a:t>C (k = 25%)</a:t>
                       </a:r>
                       <a:endParaRPr lang="en-US" sz="1400" dirty="0">
                         <a:latin typeface="Calibri" charset="0"/>
@@ -13122,7 +13304,7 @@
                   </a:tcPr>
                 </a:tc>
               </a:tr>
-              <a:tr h="777240">
+              <a:tr h="731520">
                 <a:tc>
                   <a:txBody>
                     <a:bodyPr/>
@@ -13276,7 +13458,7 @@
                           <a:ea typeface="Calibri" pitchFamily="34" charset="-122"/>
                           <a:cs typeface="Calibri" pitchFamily="34" charset="-120"/>
                         </a:rPr>
-                        <a:t>21% a 29%</a:t>
+                        <a:t>44,6%</a:t>
                       </a:r>
                       <a:endParaRPr lang="en-US" sz="1400" dirty="0">
                         <a:latin typeface="Calibri" charset="0"/>
@@ -13344,7 +13526,7 @@
                           <a:ea typeface="Calibri" pitchFamily="34" charset="-122"/>
                           <a:cs typeface="Calibri" pitchFamily="34" charset="-120"/>
                         </a:rPr>
-                        <a:t>517 (R1) | 244 (R2)</a:t>
+                        <a:t>28,9%</a:t>
                       </a:r>
                       <a:endParaRPr lang="en-US" sz="1400" dirty="0">
                         <a:latin typeface="Calibri" charset="0"/>
@@ -13396,7 +13578,7 @@
                   </a:tcPr>
                 </a:tc>
               </a:tr>
-              <a:tr h="777240">
+              <a:tr h="731520">
                 <a:tc>
                   <a:txBody>
                     <a:bodyPr/>
@@ -13550,7 +13732,7 @@
                           <a:ea typeface="Calibri" pitchFamily="34" charset="-122"/>
                           <a:cs typeface="Calibri" pitchFamily="34" charset="-120"/>
                         </a:rPr>
-                        <a:t>43% a 59%</a:t>
+                        <a:t>36,5%</a:t>
                       </a:r>
                       <a:endParaRPr lang="en-US" sz="1400" dirty="0">
                         <a:latin typeface="Calibri" charset="0"/>
@@ -13618,7 +13800,7 @@
                           <a:ea typeface="Calibri" pitchFamily="34" charset="-122"/>
                           <a:cs typeface="Calibri" pitchFamily="34" charset="-120"/>
                         </a:rPr>
-                        <a:t>264 (R1) | 498 (R2)</a:t>
+                        <a:t>58,9%</a:t>
                       </a:r>
                       <a:endParaRPr lang="en-US" sz="1400" dirty="0">
                         <a:latin typeface="Calibri" charset="0"/>
@@ -13670,7 +13852,7 @@
                   </a:tcPr>
                 </a:tc>
               </a:tr>
-              <a:tr h="777240">
+              <a:tr h="731520">
                 <a:tc>
                   <a:txBody>
                     <a:bodyPr/>
@@ -13824,7 +14006,7 @@
                           <a:ea typeface="Calibri" pitchFamily="34" charset="-122"/>
                           <a:cs typeface="Calibri" pitchFamily="34" charset="-120"/>
                         </a:rPr>
-                        <a:t>12% a 36%</a:t>
+                        <a:t>18,9%</a:t>
                       </a:r>
                       <a:endParaRPr lang="en-US" sz="1400" dirty="0">
                         <a:latin typeface="Calibri" charset="0"/>
@@ -13892,7 +14074,7 @@
                           <a:ea typeface="Calibri" pitchFamily="34" charset="-122"/>
                           <a:cs typeface="Calibri" pitchFamily="34" charset="-120"/>
                         </a:rPr>
-                        <a:t>219 (R1) | 258 (R2)</a:t>
+                        <a:t>12,2%</a:t>
                       </a:r>
                       <a:endParaRPr lang="en-US" sz="1400" dirty="0">
                         <a:latin typeface="Calibri" charset="0"/>
@@ -13956,8 +14138,8 @@
         </p:nvSpPr>
         <p:spPr>
           <a:xfrm>
-            <a:off x="6903720" y="4617720"/>
-            <a:ext cx="4739335" cy="822960"/>
+            <a:off x="6903720" y="4389120"/>
+            <a:ext cx="4739335" cy="1097280"/>
           </a:xfrm>
           <a:prstGeom prst="rect">
             <a:avLst/>
@@ -13978,7 +14160,7 @@
                   <a:schemeClr val="tx2"/>
                 </a:solidFill>
               </a:rPr>
-              <a:t>Valores em R$ milhões por R$ 1 bilhão de receita fixa anual. R2 usa o ponto médio das térmicas (62,5%).</a:t>
+              <a:t>Eólicas e solares fixas em P1 (100%). Hidrelétricas e térmicas usam o mesmo coeficiente k: 100% (tudo P1), 62,5% (média dos quatro patamares) e 25% (tudo P4). Para cada R$ 1 bi de receita fixa, 1% equivale a R$ 10 mi.</a:t>
             </a:r>
             <a:endParaRPr lang="en-US" sz="1200" dirty="0"/>
           </a:p>
@@ -14052,7 +14234,7 @@
                   <a:schemeClr val="bg1"/>
                 </a:solidFill>
               </a:rPr>
-              <a:t>A ANEEL ainda define a fórmula. Premissas: base = geração de 2025 (EPE); coeficientes assumidos de 25% (hidro), 100% (eólica e solar) e 25% a 100% (térmicas).</a:t>
+              <a:t>A ANEEL ainda define a fórmula e os critérios de cada patamar. Os cenários mostram o intervalo possível, com a geração de 2025 (EPE) como base.</a:t>
             </a:r>
             <a:endParaRPr lang="en-US" sz="1400" dirty="0"/>
           </a:p>
@@ -14088,7 +14270,7 @@
                   <a:schemeClr val="tx2"/>
                 </a:solidFill>
               </a:rPr>
-              <a:t>Cálculo próprio com geração de 2025 do Anuário Estatístico de Energia Elétrica 2025 (EPE): hidráulica 51,7%, eólica e solar 26,4% e demais 21,9% (resíduo).</a:t>
+              <a:t>Cálculo próprio com a geração de 2025 do Anuário Estatístico de Energia Elétrica 2025 (EPE): hidráulica 51,7%, eólica e solar 26,4% e demais 21,9% (resíduo).</a:t>
             </a:r>
             <a:endParaRPr lang="en-US" sz="1000" dirty="0"/>
           </a:p>
@@ -15306,7 +15488,7 @@
                           <a:ea typeface="Calibri" pitchFamily="34" charset="-122"/>
                           <a:cs typeface="Calibri" pitchFamily="34" charset="-120"/>
                         </a:rPr>
-                        <a:t>100%, por serem intermitentes</a:t>
+                        <a:t>Parte do P1 (100%); pode cair com armazenamento associado</a:t>
                       </a:r>
                       <a:endParaRPr lang="en-US" sz="1400" dirty="0">
                         <a:latin typeface="Calibri" charset="0"/>
@@ -15580,7 +15762,7 @@
                           <a:ea typeface="Calibri" pitchFamily="34" charset="-122"/>
                           <a:cs typeface="Calibri" pitchFamily="34" charset="-120"/>
                         </a:rPr>
-                        <a:t>De 100% a 25%, conforme a flexibilidade</a:t>
+                        <a:t>P1 a P4 (100% a 25%), conforme a classificação do ONS</a:t>
                       </a:r>
                       <a:endParaRPr lang="en-US" sz="1400" dirty="0">
                         <a:latin typeface="Calibri" charset="0"/>
@@ -15854,7 +16036,7 @@
                           <a:ea typeface="Calibri" pitchFamily="34" charset="-122"/>
                           <a:cs typeface="Calibri" pitchFamily="34" charset="-120"/>
                         </a:rPr>
-                        <a:t>Menor patamar (25%)</a:t>
+                        <a:t>P1 a P4 (100% a 25%), conforme a classificação do ONS</a:t>
                       </a:r>
                       <a:endParaRPr lang="en-US" sz="1400" dirty="0">
                         <a:latin typeface="Calibri" charset="0"/>
@@ -15990,7 +16172,7 @@
                           <a:ea typeface="Calibri" pitchFamily="34" charset="-122"/>
                           <a:cs typeface="Calibri" pitchFamily="34" charset="-120"/>
                         </a:rPr>
-                        <a:t>Tende a ser positivo</a:t>
+                        <a:t>Depende do patamar e do ganho hídrico</a:t>
                       </a:r>
                       <a:endParaRPr lang="en-US" sz="1400" dirty="0">
                         <a:latin typeface="Calibri" charset="0"/>
@@ -16424,7 +16606,7 @@
                   <a:schemeClr val="tx2"/>
                 </a:solidFill>
               </a:rPr>
-              <a:t>Encargos: proposta da ANEEL (NT 101/2026) e Agência iNFRA (2026). Os sinais do saldo são hipóteses de trabalho, não resultados.</a:t>
+              <a:t>Encargos: proposta da ANEEL (NT 101/2026), via resumos setoriais. Os sinais do saldo são hipóteses de trabalho, não resultados.</a:t>
             </a:r>
             <a:endParaRPr lang="en-US" sz="1000" dirty="0"/>
           </a:p>

</xml_diff>

<commit_message>
Refaz slide da curva do pato com dados abertos do ONS (10/08/2025)
Co-Authored-By: Claude Sonnet 5.5 <noreply@anthropic.com>
Claude-Session: https://claude.ai/code/session_018oVMGfcbhG1itrwj795JhB
</commit_message>
<xml_diff>
--- a/Baterias_SIN_Economia_Setor_Eletrico_I.pptx
+++ b/Baterias_SIN_Economia_Setor_Eletrico_I.pptx
@@ -131,12 +131,12 @@
   <p:extLst>
     <p:ext uri="{521415D9-36F7-43E2-AB2F-B90AF26B5E84}">
       <p14:sectionLst xmlns:p14="http://schemas.microsoft.com/office/powerpoint/2010/main">
-        <p14:section name="Abertura" id="{66bbd201-a693-5c9e-804d-3811eec1350e}">
+        <p14:section name="Abertura" id="{22d14a1a-359c-07cc-bf6c-f406d29c2f44}">
           <p14:sldIdLst>
             <p14:sldId id="256"/>
           </p14:sldIdLst>
         </p14:section>
-        <p14:section name="Introdução" id="{b961fbde-c4eb-606c-e181-03b366a58069}">
+        <p14:section name="Introdução" id="{ff90a364-07fa-5700-7b24-b3974b2bbdce}">
           <p14:sldIdLst>
             <p14:sldId id="257"/>
             <p14:sldId id="258"/>
@@ -145,13 +145,13 @@
             <p14:sldId id="261"/>
           </p14:sldIdLst>
         </p14:section>
-        <p14:section name="Objetivos" id="{885a9312-f992-282f-d21d-025d68800ca3}">
+        <p14:section name="Objetivos" id="{b145d3b4-46f3-d0bf-b640-bbd0af6ad0a6}">
           <p14:sldIdLst>
             <p14:sldId id="262"/>
             <p14:sldId id="263"/>
           </p14:sldIdLst>
         </p14:section>
-        <p14:section name="Método" id="{80bd6b9b-a47a-ce54-e344-70ae784eb013}">
+        <p14:section name="Método" id="{4a15fffa-de2f-08e4-f8e5-cb8b23b29b9f}">
           <p14:sldIdLst>
             <p14:sldId id="264"/>
             <p14:sldId id="265"/>
@@ -159,13 +159,13 @@
             <p14:sldId id="267"/>
           </p14:sldIdLst>
         </p14:section>
-        <p14:section name="Análise" id="{501ec1aa-cd57-8916-9117-6eef78707400}">
+        <p14:section name="Análise" id="{7055d899-ff08-dc86-96d3-4e366a1d16da}">
           <p14:sldIdLst>
             <p14:sldId id="268"/>
             <p14:sldId id="269"/>
           </p14:sldIdLst>
         </p14:section>
-        <p14:section name="Encargos e benefícios" id="{eb95b551-7e7e-af02-0739-3141f371b355}">
+        <p14:section name="Encargos e benefícios" id="{c464c56f-cfd6-fb6b-75cc-b4faacc37738}">
           <p14:sldIdLst>
             <p14:sldId id="270"/>
             <p14:sldId id="271"/>
@@ -178,7 +178,7 @@
             <p14:sldId id="278"/>
           </p14:sldIdLst>
         </p14:section>
-        <p14:section name="Fechamento" id="{66e1ebd0-5d08-8f76-c89c-abcefa339038}">
+        <p14:section name="Fechamento" id="{452ce5d8-ce11-c07b-94de-08d60050caf0}">
           <p14:sldIdLst>
             <p14:sldId id="279"/>
             <p14:sldId id="280"/>
@@ -219,7 +219,7 @@
                 </a:solidFill>
                 <a:latin typeface="+mn-lt"/>
               </a:rPr>
-              <a:t>Perfil diário ilustrativo (índice, sem dados reais)</a:t>
+              <a:t>SIN, domingo 10/08/2025 (GW por hora)</a:t>
             </a:r>
           </a:p>
         </c:rich>
@@ -390,76 +390,76 @@
                 <c:formatCode>General</c:formatCode>
                 <c:ptCount val="24"/>
                 <c:pt idx="0">
-                  <c:v>52</c:v>
+                  <c:v>65.13</c:v>
                 </c:pt>
                 <c:pt idx="1">
-                  <c:v>52</c:v>
+                  <c:v>61.87</c:v>
                 </c:pt>
                 <c:pt idx="2">
-                  <c:v>52</c:v>
+                  <c:v>59.65</c:v>
                 </c:pt>
                 <c:pt idx="3">
-                  <c:v>52</c:v>
+                  <c:v>58.23</c:v>
                 </c:pt>
                 <c:pt idx="4">
-                  <c:v>52</c:v>
+                  <c:v>57.47</c:v>
                 </c:pt>
                 <c:pt idx="5">
-                  <c:v>52.1</c:v>
+                  <c:v>56.94</c:v>
                 </c:pt>
                 <c:pt idx="6">
-                  <c:v>52.3</c:v>
+                  <c:v>56.4</c:v>
                 </c:pt>
                 <c:pt idx="7">
-                  <c:v>52.7</c:v>
+                  <c:v>56.72</c:v>
                 </c:pt>
                 <c:pt idx="8">
-                  <c:v>53.8</c:v>
+                  <c:v>57.24</c:v>
                 </c:pt>
                 <c:pt idx="9">
-                  <c:v>55.8</c:v>
+                  <c:v>58.13</c:v>
                 </c:pt>
                 <c:pt idx="10">
-                  <c:v>58.7</c:v>
+                  <c:v>59.73</c:v>
                 </c:pt>
                 <c:pt idx="11">
-                  <c:v>62.1</c:v>
+                  <c:v>60.58</c:v>
                 </c:pt>
                 <c:pt idx="12">
-                  <c:v>64.9</c:v>
+                  <c:v>58.98</c:v>
                 </c:pt>
                 <c:pt idx="13">
-                  <c:v>66</c:v>
+                  <c:v>56.55</c:v>
                 </c:pt>
                 <c:pt idx="14">
-                  <c:v>64.9</c:v>
+                  <c:v>55.13</c:v>
                 </c:pt>
                 <c:pt idx="15">
-                  <c:v>62.5</c:v>
+                  <c:v>56.07</c:v>
                 </c:pt>
                 <c:pt idx="16">
-                  <c:v>60.6</c:v>
+                  <c:v>60.32</c:v>
                 </c:pt>
                 <c:pt idx="17">
-                  <c:v>62.4</c:v>
+                  <c:v>68.72</c:v>
                 </c:pt>
                 <c:pt idx="18">
-                  <c:v>68.9</c:v>
+                  <c:v>78.06</c:v>
                 </c:pt>
                 <c:pt idx="19">
-                  <c:v>75.5</c:v>
+                  <c:v>78.2</c:v>
                 </c:pt>
                 <c:pt idx="20">
-                  <c:v>75</c:v>
+                  <c:v>76.48</c:v>
                 </c:pt>
                 <c:pt idx="21">
-                  <c:v>67.2</c:v>
+                  <c:v>74.89</c:v>
                 </c:pt>
                 <c:pt idx="22">
-                  <c:v>58.6</c:v>
+                  <c:v>71.63</c:v>
                 </c:pt>
                 <c:pt idx="23">
-                  <c:v>53.9</c:v>
+                  <c:v>67.38</c:v>
                 </c:pt>
               </c:numCache>
             </c:numRef>
@@ -475,7 +475,7 @@
               <c:strCache>
                 <c:ptCount val="1"/>
                 <c:pt idx="0">
-                  <c:v>MMGD solar</c:v>
+                  <c:v>MMGD</c:v>
                 </c:pt>
               </c:strCache>
             </c:strRef>
@@ -639,46 +639,46 @@
                   <c:v>0</c:v>
                 </c:pt>
                 <c:pt idx="5">
-                  <c:v>0</c:v>
+                  <c:v>0.11</c:v>
                 </c:pt>
                 <c:pt idx="6">
-                  <c:v>0</c:v>
+                  <c:v>1.49</c:v>
                 </c:pt>
                 <c:pt idx="7">
-                  <c:v>3.4</c:v>
+                  <c:v>6.02</c:v>
                 </c:pt>
                 <c:pt idx="8">
-                  <c:v>9.2</c:v>
+                  <c:v>12.12</c:v>
                 </c:pt>
                 <c:pt idx="9">
-                  <c:v>15.5</c:v>
+                  <c:v>17.51</c:v>
                 </c:pt>
                 <c:pt idx="10">
-                  <c:v>21</c:v>
+                  <c:v>21.45</c:v>
                 </c:pt>
                 <c:pt idx="11">
-                  <c:v>24.7</c:v>
+                  <c:v>23.35</c:v>
                 </c:pt>
                 <c:pt idx="12">
-                  <c:v>26</c:v>
+                  <c:v>23.22</c:v>
                 </c:pt>
                 <c:pt idx="13">
-                  <c:v>24.7</c:v>
+                  <c:v>21.08</c:v>
                 </c:pt>
                 <c:pt idx="14">
-                  <c:v>21</c:v>
+                  <c:v>17.22</c:v>
                 </c:pt>
                 <c:pt idx="15">
-                  <c:v>15.5</c:v>
+                  <c:v>11.97</c:v>
                 </c:pt>
                 <c:pt idx="16">
-                  <c:v>9.2</c:v>
+                  <c:v>6</c:v>
                 </c:pt>
                 <c:pt idx="17">
-                  <c:v>3.4</c:v>
+                  <c:v>1.32</c:v>
                 </c:pt>
                 <c:pt idx="18">
-                  <c:v>0</c:v>
+                  <c:v>0.06</c:v>
                 </c:pt>
                 <c:pt idx="19">
                   <c:v>0</c:v>
@@ -709,7 +709,7 @@
               <c:strCache>
                 <c:ptCount val="1"/>
                 <c:pt idx="0">
-                  <c:v>Carga líquida</c:v>
+                  <c:v>Carga líquida (bruta − MMGD)</c:v>
                 </c:pt>
               </c:strCache>
             </c:strRef>
@@ -858,76 +858,76 @@
                 <c:formatCode>General</c:formatCode>
                 <c:ptCount val="24"/>
                 <c:pt idx="0">
-                  <c:v>52</c:v>
+                  <c:v>65.13</c:v>
                 </c:pt>
                 <c:pt idx="1">
-                  <c:v>52</c:v>
+                  <c:v>61.87</c:v>
                 </c:pt>
                 <c:pt idx="2">
-                  <c:v>52</c:v>
+                  <c:v>59.65</c:v>
                 </c:pt>
                 <c:pt idx="3">
-                  <c:v>52</c:v>
+                  <c:v>58.23</c:v>
                 </c:pt>
                 <c:pt idx="4">
-                  <c:v>52</c:v>
+                  <c:v>57.47</c:v>
                 </c:pt>
                 <c:pt idx="5">
-                  <c:v>52.1</c:v>
+                  <c:v>56.82</c:v>
                 </c:pt>
                 <c:pt idx="6">
-                  <c:v>52.3</c:v>
+                  <c:v>54.91</c:v>
                 </c:pt>
                 <c:pt idx="7">
-                  <c:v>49.3</c:v>
+                  <c:v>50.7</c:v>
                 </c:pt>
                 <c:pt idx="8">
-                  <c:v>44.6</c:v>
+                  <c:v>45.12</c:v>
                 </c:pt>
                 <c:pt idx="9">
-                  <c:v>40.3</c:v>
+                  <c:v>40.62</c:v>
                 </c:pt>
                 <c:pt idx="10">
-                  <c:v>37.8</c:v>
+                  <c:v>38.29</c:v>
                 </c:pt>
                 <c:pt idx="11">
-                  <c:v>37.4</c:v>
+                  <c:v>37.23</c:v>
                 </c:pt>
                 <c:pt idx="12">
-                  <c:v>38.9</c:v>
+                  <c:v>35.76</c:v>
                 </c:pt>
                 <c:pt idx="13">
-                  <c:v>41.3</c:v>
+                  <c:v>35.47</c:v>
                 </c:pt>
                 <c:pt idx="14">
-                  <c:v>44</c:v>
+                  <c:v>37.91</c:v>
                 </c:pt>
                 <c:pt idx="15">
-                  <c:v>47</c:v>
+                  <c:v>44.11</c:v>
                 </c:pt>
                 <c:pt idx="16">
-                  <c:v>51.4</c:v>
+                  <c:v>54.32</c:v>
                 </c:pt>
                 <c:pt idx="17">
-                  <c:v>59</c:v>
+                  <c:v>67.4</c:v>
                 </c:pt>
                 <c:pt idx="18">
-                  <c:v>68.9</c:v>
+                  <c:v>78</c:v>
                 </c:pt>
                 <c:pt idx="19">
-                  <c:v>75.5</c:v>
+                  <c:v>78.2</c:v>
                 </c:pt>
                 <c:pt idx="20">
-                  <c:v>75</c:v>
+                  <c:v>76.48</c:v>
                 </c:pt>
                 <c:pt idx="21">
-                  <c:v>67.2</c:v>
+                  <c:v>74.89</c:v>
                 </c:pt>
                 <c:pt idx="22">
-                  <c:v>58.6</c:v>
+                  <c:v>71.63</c:v>
                 </c:pt>
                 <c:pt idx="23">
-                  <c:v>53.9</c:v>
+                  <c:v>67.38</c:v>
                 </c:pt>
               </c:numCache>
             </c:numRef>
@@ -1011,7 +1011,7 @@
           <c:max val="90"/>
           <c:min val="0"/>
         </c:scaling>
-        <c:delete val="1"/>
+        <c:delete val="0"/>
         <c:axPos val="l"/>
         <c:majorGridlines>
           <c:spPr>
@@ -1044,9 +1044,9 @@
             <a:pPr>
               <a:defRPr sz="1200" b="0" i="0" u="none" strike="noStrike">
                 <a:solidFill>
-                  <a:srgbClr val="000000"/>
-                </a:solidFill>
-                <a:latin typeface="Arial"/>
+                  <a:srgbClr val="5B6B80"/>
+                </a:solidFill>
+                <a:latin typeface="+mn-lt"/>
               </a:defRPr>
             </a:pPr>
             <a:endParaRPr lang="en-US"/>
@@ -1055,6 +1055,7 @@
         <c:crossAx val="2094734554"/>
         <c:crosses val="autoZero"/>
         <c:crossBetween val="between"/>
+        <c:majorUnit val="15"/>
       </c:valAx>
       <c:spPr>
         <a:noFill/>
@@ -3913,7 +3914,7 @@
           <a:p>
             <a:r>
               <a:rPr lang="en-US" dirty="0"/>
-              <a:t>A curva do pato foi popularizada pelo operador da Califórnia (CAISO) em 2013. A carga líquida é a carga bruta menos a geração variável: a EPE define a carga líquida como a carga bruta descontada da MMGD fotovoltaica e de outros geradores não representados, e a versão usada pelo setor também desconta eólica e solar centralizada. O gráfico é um perfil ilustrativo, calculado com funções suaves, e não usa dados reais. A MMGD faz a carga líquida afundar ao meio-dia (barriga) e depois subir rápido no fim da tarde (pescoço). Hidrelétricas e térmicas respondem pela rampa; o Ipea cita 82,7% e 17,3% em agosto de 2024. A projeção do ONS para 2029 indica rampas acima de 40 GW em poucas horas.</a:t>
+              <a:t>Curva real do SIN em 10/08/2025, um domingo e o dia do episódio de excedente citado pelo setor. Os dados são os dados abertos do ONS em base horária: a carga vem do balanço de energia nos subsistemas (linha SIN), e a MMGD é a modalidade 'Pequenas Usinas (MMGD)' do conjunto de geração por usina, que é uma estimativa do ONS. A soma de MMGD e solar centralizada reproduz a geração solar do balanço, e a geração total reproduz a carga, o que indica que a carga do ONS é a carga bruta, incluindo a parcela atendida pela MMGD. Carga líquida = carga bruta menos MMGD, que é a definição da EPE; a versão ampla também desconta eólica e solar centralizada. Resultados do dia: MMGD de 23,2 GW às 12h, equivalente a 39,4% da carga de 59,0 GW; carga líquida mínima de 35,5 GW às 13h e máxima de 78,2 GW às 19h; rampa de 33,9 GW entre 15h e 18h. A solar centralizada gerou 0,5 GW às 12h, contra 7,3 GW na média de agosto. A média de agosto/2025 (31 dias) mostra o mesmo formato, com carga líquida de 51,9 GW às 12h e 87,8 GW às 18h.</a:t>
             </a:r>
             <a:endParaRPr lang="en-US" dirty="0"/>
           </a:p>
@@ -29964,26 +29965,7 @@
                   <a:schemeClr val="tx1"/>
                 </a:solidFill>
               </a:rPr>
-              <a:t>Ipea. Estudo sobre a rampa da carga líquida e as renováveis variáveis no SIN (repositório Ipea).</a:t>
-            </a:r>
-            <a:endParaRPr lang="en-US" sz="1200" dirty="0"/>
-          </a:p>
-          <a:p>
-            <a:pPr marL="342900" indent="-342900">
-              <a:spcAft>
-                <a:spcPts val="600"/>
-              </a:spcAft>
-              <a:buSzPct val="100000"/>
-              <a:buFont typeface="+mj-lt"/>
-              <a:buAutoNum type="arabicPeriod" startAt="13"/>
-            </a:pPr>
-            <a:r>
-              <a:rPr lang="en-US" sz="1200" dirty="0">
-                <a:solidFill>
-                  <a:schemeClr val="tx1"/>
-                </a:solidFill>
-              </a:rPr>
-              <a:t>Abraceel (2023). Contribuição à revisão dos PR para inclusão da MMGD na previsão de carga.</a:t>
+              <a:t>ONS (2026). Dados abertos: balanço de energia nos subsistemas e geração por usina, base horária, 2025.</a:t>
             </a:r>
             <a:endParaRPr lang="en-US" sz="1200" dirty="0"/>
           </a:p>
@@ -31733,7 +31715,7 @@
                   <a:schemeClr val="tx1"/>
                 </a:solidFill>
               </a:rPr>
-              <a:t>A curva do pato: carga bruta, MMGD e carga líquida</a:t>
+              <a:t>A curva do pato no SIN: domingo, 10/08/2025</a:t>
             </a:r>
             <a:endParaRPr lang="en-US" sz="3200" dirty="0"/>
           </a:p>
@@ -31748,7 +31730,7 @@
         <p:spPr>
           <a:xfrm>
             <a:off x="548640" y="1371600"/>
-            <a:ext cx="6400800" cy="4023360"/>
+            <a:ext cx="6675120" cy="4023360"/>
           </a:xfrm>
           <a:prstGeom prst="roundRect">
             <a:avLst>
@@ -31781,7 +31763,7 @@
         </p:nvGraphicFramePr>
         <p:xfrm>
           <a:off x="685800" y="1463040"/>
-          <a:ext cx="6126480" cy="3291840"/>
+          <a:ext cx="6400800" cy="3840480"/>
         </p:xfrm>
         <a:graphic xmlns:a="http://schemas.openxmlformats.org/drawingml/2006/main">
           <a:graphicData uri="http://schemas.openxmlformats.org/drawingml/2006/chart">
@@ -31791,140 +31773,14 @@
       </p:graphicFrame>
       <p:sp>
         <p:nvSpPr>
-          <p:cNvPr id="5" name="Duck callout 1"/>
+          <p:cNvPr id="5" name="Duck stat 1"/>
           <p:cNvSpPr/>
           <p:nvPr/>
         </p:nvSpPr>
         <p:spPr>
           <a:xfrm>
-            <a:off x="822960" y="4846320"/>
-            <a:ext cx="2834640" cy="384048"/>
-          </a:xfrm>
-          <a:prstGeom prst="roundRect">
-            <a:avLst>
-              <a:gd name="adj" fmla="val 23810"/>
-            </a:avLst>
-          </a:prstGeom>
-          <a:solidFill>
-            <a:schemeClr val="accent4"/>
-          </a:solidFill>
-          <a:ln w="12700">
-            <a:solidFill>
-              <a:schemeClr val="accent4"/>
-            </a:solidFill>
-            <a:prstDash val="solid"/>
-          </a:ln>
-        </p:spPr>
-      </p:sp>
-      <p:sp>
-        <p:nvSpPr>
-          <p:cNvPr id="6" name="Text 3"/>
-          <p:cNvSpPr txBox="1"/>
-          <p:nvPr/>
-        </p:nvSpPr>
-        <p:spPr>
-          <a:xfrm>
-            <a:off x="822960" y="4846320"/>
-            <a:ext cx="2834640" cy="384048"/>
-          </a:xfrm>
-          <a:prstGeom prst="rect">
-            <a:avLst/>
-          </a:prstGeom>
-          <a:noFill/>
-          <a:ln/>
-        </p:spPr>
-        <p:txBody>
-          <a:bodyPr wrap="square" lIns="0" tIns="0" rIns="0" bIns="0" rtlCol="0" anchor="ctr"/>
-          <a:lstStyle/>
-          <a:p>
-            <a:pPr algn="ctr" indent="0" marL="0">
-              <a:buNone/>
-            </a:pPr>
-            <a:r>
-              <a:rPr lang="en-US" sz="1300" b="1" dirty="0">
-                <a:solidFill>
-                  <a:schemeClr val="bg1"/>
-                </a:solidFill>
-              </a:rPr>
-              <a:t>Barriga: excesso ao meio-dia</a:t>
-            </a:r>
-            <a:endParaRPr lang="en-US" sz="1300" dirty="0"/>
-          </a:p>
-        </p:txBody>
-      </p:sp>
-      <p:sp>
-        <p:nvSpPr>
-          <p:cNvPr id="7" name="Duck callout 2"/>
-          <p:cNvSpPr/>
-          <p:nvPr/>
-        </p:nvSpPr>
-        <p:spPr>
-          <a:xfrm>
-            <a:off x="3886200" y="4846320"/>
-            <a:ext cx="2834640" cy="384048"/>
-          </a:xfrm>
-          <a:prstGeom prst="roundRect">
-            <a:avLst>
-              <a:gd name="adj" fmla="val 23810"/>
-            </a:avLst>
-          </a:prstGeom>
-          <a:solidFill>
-            <a:schemeClr val="accent1"/>
-          </a:solidFill>
-          <a:ln w="12700">
-            <a:solidFill>
-              <a:schemeClr val="accent1"/>
-            </a:solidFill>
-            <a:prstDash val="solid"/>
-          </a:ln>
-        </p:spPr>
-      </p:sp>
-      <p:sp>
-        <p:nvSpPr>
-          <p:cNvPr id="8" name="Text 5"/>
-          <p:cNvSpPr txBox="1"/>
-          <p:nvPr/>
-        </p:nvSpPr>
-        <p:spPr>
-          <a:xfrm>
-            <a:off x="3886200" y="4846320"/>
-            <a:ext cx="2834640" cy="384048"/>
-          </a:xfrm>
-          <a:prstGeom prst="rect">
-            <a:avLst/>
-          </a:prstGeom>
-          <a:noFill/>
-          <a:ln/>
-        </p:spPr>
-        <p:txBody>
-          <a:bodyPr wrap="square" lIns="0" tIns="0" rIns="0" bIns="0" rtlCol="0" anchor="ctr"/>
-          <a:lstStyle/>
-          <a:p>
-            <a:pPr algn="ctr" indent="0" marL="0">
-              <a:buNone/>
-            </a:pPr>
-            <a:r>
-              <a:rPr lang="en-US" sz="1300" b="1" dirty="0">
-                <a:solidFill>
-                  <a:schemeClr val="tx1"/>
-                </a:solidFill>
-              </a:rPr>
-              <a:t>Pescoço: rampa no fim da tarde</a:t>
-            </a:r>
-            <a:endParaRPr lang="en-US" sz="1300" dirty="0"/>
-          </a:p>
-        </p:txBody>
-      </p:sp>
-      <p:sp>
-        <p:nvSpPr>
-          <p:cNvPr id="9" name="Definition 1"/>
-          <p:cNvSpPr/>
-          <p:nvPr/>
-        </p:nvSpPr>
-        <p:spPr>
-          <a:xfrm>
-            <a:off x="7223760" y="1371600"/>
-            <a:ext cx="4419295" cy="1234440"/>
+            <a:off x="7498080" y="1371600"/>
+            <a:ext cx="4144975" cy="1234440"/>
           </a:xfrm>
           <a:prstGeom prst="roundRect">
             <a:avLst>
@@ -31951,63 +31807,41 @@
       </p:sp>
       <p:sp>
         <p:nvSpPr>
-          <p:cNvPr id="10" name="Icon circle"/>
+          <p:cNvPr id="6" name="Duck stat tag 1"/>
           <p:cNvSpPr/>
           <p:nvPr/>
         </p:nvSpPr>
         <p:spPr>
           <a:xfrm>
-            <a:off x="7452360" y="1691640"/>
-            <a:ext cx="548640" cy="548640"/>
-          </a:xfrm>
-          <a:prstGeom prst="ellipse">
-            <a:avLst/>
+            <a:off x="7680960" y="1600200"/>
+            <a:ext cx="1417320" cy="777240"/>
+          </a:xfrm>
+          <a:prstGeom prst="roundRect">
+            <a:avLst>
+              <a:gd name="adj" fmla="val 11765"/>
+            </a:avLst>
           </a:prstGeom>
           <a:solidFill>
-            <a:schemeClr val="accent3"/>
+            <a:schemeClr val="accent1"/>
           </a:solidFill>
           <a:ln w="12700">
             <a:solidFill>
-              <a:schemeClr val="accent3"/>
+              <a:schemeClr val="accent1"/>
             </a:solidFill>
             <a:prstDash val="solid"/>
           </a:ln>
         </p:spPr>
       </p:sp>
-      <p:pic>
-        <p:nvPicPr>
-          <p:cNvPr id="11" name="Image 0" descr="FaBolt">    </p:cNvPr>
-          <p:cNvPicPr>
-            <a:picLocks noChangeAspect="1"/>
-          </p:cNvPicPr>
-          <p:nvPr/>
-        </p:nvPicPr>
-        <p:blipFill>
-          <a:blip r:embed="rId2"/>
-          <a:stretch>
-            <a:fillRect/>
-          </a:stretch>
-        </p:blipFill>
-        <p:spPr>
-          <a:xfrm>
-            <a:off x="7589520" y="1828800"/>
-            <a:ext cx="274320" cy="274320"/>
-          </a:xfrm>
-          <a:prstGeom prst="rect">
-            <a:avLst/>
-          </a:prstGeom>
-        </p:spPr>
-      </p:pic>
-      <p:sp>
-        <p:nvSpPr>
-          <p:cNvPr id="12" name="Text 8"/>
+      <p:sp>
+        <p:nvSpPr>
+          <p:cNvPr id="7" name="Text 4"/>
           <p:cNvSpPr txBox="1"/>
           <p:nvPr/>
         </p:nvSpPr>
         <p:spPr>
           <a:xfrm>
-            <a:off x="8229600" y="1481328"/>
-            <a:ext cx="3230575" cy="365760"/>
+            <a:off x="7680960" y="1600200"/>
+            <a:ext cx="1417320" cy="777240"/>
           </a:xfrm>
           <a:prstGeom prst="rect">
             <a:avLst/>
@@ -32016,14 +31850,16 @@
           <a:ln/>
         </p:spPr>
         <p:txBody>
-          <a:bodyPr wrap="square" lIns="0" tIns="0" rIns="0" bIns="0" rtlCol="0" anchor="ctr"/>
+          <a:bodyPr wrap="square" lIns="0" tIns="0" rIns="0" bIns="0" rtlCol="0" anchor="ctr">
+            <a:normAutofit/>
+          </a:bodyPr>
           <a:lstStyle/>
           <a:p>
-            <a:pPr indent="0" marL="0">
+            <a:pPr algn="ctr" indent="0" marL="0">
               <a:buNone/>
             </a:pPr>
             <a:r>
-              <a:rPr lang="en-US" sz="1600" b="1" dirty="0">
+              <a:rPr lang="en-US" sz="2200" b="1" dirty="0">
                 <a:solidFill>
                   <a:schemeClr val="tx1"/>
                 </a:solidFill>
@@ -32031,22 +31867,22 @@
                 <a:ea typeface="Cambria" pitchFamily="34" charset="-122"/>
                 <a:cs typeface="Cambria" pitchFamily="34" charset="-120"/>
               </a:rPr>
-              <a:t>Carga bruta</a:t>
-            </a:r>
-            <a:endParaRPr lang="en-US" sz="1600" dirty="0"/>
-          </a:p>
-        </p:txBody>
-      </p:sp>
-      <p:sp>
-        <p:nvSpPr>
-          <p:cNvPr id="13" name="Text 9"/>
+              <a:t>39%</a:t>
+            </a:r>
+            <a:endParaRPr lang="en-US" sz="2200" dirty="0"/>
+          </a:p>
+        </p:txBody>
+      </p:sp>
+      <p:sp>
+        <p:nvSpPr>
+          <p:cNvPr id="8" name="Text 5"/>
           <p:cNvSpPr txBox="1"/>
           <p:nvPr/>
         </p:nvSpPr>
         <p:spPr>
           <a:xfrm>
-            <a:off x="8229600" y="1874520"/>
-            <a:ext cx="3230575" cy="685800"/>
+            <a:off x="9281160" y="1463040"/>
+            <a:ext cx="2179015" cy="1051560"/>
           </a:xfrm>
           <a:prstGeom prst="rect">
             <a:avLst/>
@@ -32055,7 +31891,7 @@
           <a:ln/>
         </p:spPr>
         <p:txBody>
-          <a:bodyPr wrap="square" lIns="0" tIns="0" rIns="0" bIns="0" rtlCol="0" anchor="t"/>
+          <a:bodyPr wrap="square" lIns="0" tIns="0" rIns="0" bIns="0" rtlCol="0" anchor="ctr"/>
           <a:lstStyle/>
           <a:p>
             <a:pPr indent="0" marL="0">
@@ -32064,10 +31900,10 @@
             <a:r>
               <a:rPr lang="en-US" sz="1300" dirty="0">
                 <a:solidFill>
-                  <a:schemeClr val="tx2"/>
-                </a:solidFill>
-              </a:rPr>
-              <a:t>Consumo total de potência, inclusive o atendido atrás do medidor.</a:t>
+                  <a:schemeClr val="tx1"/>
+                </a:solidFill>
+              </a:rPr>
+              <a:t>da carga às 12h foi atendida pela MMGD: 23,2 de 59,0 GW.</a:t>
             </a:r>
             <a:endParaRPr lang="en-US" sz="1300" dirty="0"/>
           </a:p>
@@ -32075,14 +31911,14 @@
       </p:sp>
       <p:sp>
         <p:nvSpPr>
-          <p:cNvPr id="14" name="Definition 2"/>
+          <p:cNvPr id="9" name="Duck stat 2"/>
           <p:cNvSpPr/>
           <p:nvPr/>
         </p:nvSpPr>
         <p:spPr>
           <a:xfrm>
-            <a:off x="7223760" y="2743200"/>
-            <a:ext cx="4419295" cy="1234440"/>
+            <a:off x="7498080" y="2743200"/>
+            <a:ext cx="4144975" cy="1234440"/>
           </a:xfrm>
           <a:prstGeom prst="roundRect">
             <a:avLst>
@@ -32109,63 +31945,41 @@
       </p:sp>
       <p:sp>
         <p:nvSpPr>
-          <p:cNvPr id="15" name="Icon circle"/>
+          <p:cNvPr id="10" name="Duck stat tag 2"/>
           <p:cNvSpPr/>
           <p:nvPr/>
         </p:nvSpPr>
         <p:spPr>
           <a:xfrm>
-            <a:off x="7452360" y="3063240"/>
-            <a:ext cx="548640" cy="548640"/>
-          </a:xfrm>
-          <a:prstGeom prst="ellipse">
-            <a:avLst/>
+            <a:off x="7680960" y="2971800"/>
+            <a:ext cx="1417320" cy="777240"/>
+          </a:xfrm>
+          <a:prstGeom prst="roundRect">
+            <a:avLst>
+              <a:gd name="adj" fmla="val 11765"/>
+            </a:avLst>
           </a:prstGeom>
           <a:solidFill>
-            <a:schemeClr val="accent1"/>
+            <a:schemeClr val="accent4"/>
           </a:solidFill>
           <a:ln w="12700">
             <a:solidFill>
-              <a:schemeClr val="accent1"/>
+              <a:schemeClr val="accent4"/>
             </a:solidFill>
             <a:prstDash val="solid"/>
           </a:ln>
         </p:spPr>
       </p:sp>
-      <p:pic>
-        <p:nvPicPr>
-          <p:cNvPr id="16" name="Image 1" descr="FaSolarPanel">    </p:cNvPr>
-          <p:cNvPicPr>
-            <a:picLocks noChangeAspect="1"/>
-          </p:cNvPicPr>
-          <p:nvPr/>
-        </p:nvPicPr>
-        <p:blipFill>
-          <a:blip r:embed="rId3"/>
-          <a:stretch>
-            <a:fillRect/>
-          </a:stretch>
-        </p:blipFill>
-        <p:spPr>
-          <a:xfrm>
-            <a:off x="7589520" y="3200400"/>
-            <a:ext cx="274320" cy="274320"/>
-          </a:xfrm>
-          <a:prstGeom prst="rect">
-            <a:avLst/>
-          </a:prstGeom>
-        </p:spPr>
-      </p:pic>
-      <p:sp>
-        <p:nvSpPr>
-          <p:cNvPr id="17" name="Text 12"/>
+      <p:sp>
+        <p:nvSpPr>
+          <p:cNvPr id="11" name="Text 8"/>
           <p:cNvSpPr txBox="1"/>
           <p:nvPr/>
         </p:nvSpPr>
         <p:spPr>
           <a:xfrm>
-            <a:off x="8229600" y="2852928"/>
-            <a:ext cx="3230575" cy="365760"/>
+            <a:off x="7680960" y="2971800"/>
+            <a:ext cx="1417320" cy="777240"/>
           </a:xfrm>
           <a:prstGeom prst="rect">
             <a:avLst/>
@@ -32174,37 +31988,39 @@
           <a:ln/>
         </p:spPr>
         <p:txBody>
-          <a:bodyPr wrap="square" lIns="0" tIns="0" rIns="0" bIns="0" rtlCol="0" anchor="ctr"/>
+          <a:bodyPr wrap="square" lIns="0" tIns="0" rIns="0" bIns="0" rtlCol="0" anchor="ctr">
+            <a:normAutofit/>
+          </a:bodyPr>
           <a:lstStyle/>
           <a:p>
-            <a:pPr indent="0" marL="0">
+            <a:pPr algn="ctr" indent="0" marL="0">
               <a:buNone/>
             </a:pPr>
             <a:r>
-              <a:rPr lang="en-US" sz="1600" b="1" dirty="0">
-                <a:solidFill>
-                  <a:schemeClr val="tx1"/>
+              <a:rPr lang="en-US" sz="2200" b="1" dirty="0">
+                <a:solidFill>
+                  <a:schemeClr val="bg1"/>
                 </a:solidFill>
                 <a:latin typeface="Cambria" pitchFamily="34" charset="0"/>
                 <a:ea typeface="Cambria" pitchFamily="34" charset="-122"/>
                 <a:cs typeface="Cambria" pitchFamily="34" charset="-120"/>
               </a:rPr>
-              <a:t>MMGD</a:t>
-            </a:r>
-            <a:endParaRPr lang="en-US" sz="1600" dirty="0"/>
-          </a:p>
-        </p:txBody>
-      </p:sp>
-      <p:sp>
-        <p:nvSpPr>
-          <p:cNvPr id="18" name="Text 13"/>
+              <a:t>+34 GW</a:t>
+            </a:r>
+            <a:endParaRPr lang="en-US" sz="2200" dirty="0"/>
+          </a:p>
+        </p:txBody>
+      </p:sp>
+      <p:sp>
+        <p:nvSpPr>
+          <p:cNvPr id="12" name="Text 9"/>
           <p:cNvSpPr txBox="1"/>
           <p:nvPr/>
         </p:nvSpPr>
         <p:spPr>
           <a:xfrm>
-            <a:off x="8229600" y="3246120"/>
-            <a:ext cx="3230575" cy="685800"/>
+            <a:off x="9281160" y="2834640"/>
+            <a:ext cx="2179015" cy="1051560"/>
           </a:xfrm>
           <a:prstGeom prst="rect">
             <a:avLst/>
@@ -32213,7 +32029,7 @@
           <a:ln/>
         </p:spPr>
         <p:txBody>
-          <a:bodyPr wrap="square" lIns="0" tIns="0" rIns="0" bIns="0" rtlCol="0" anchor="t"/>
+          <a:bodyPr wrap="square" lIns="0" tIns="0" rIns="0" bIns="0" rtlCol="0" anchor="ctr"/>
           <a:lstStyle/>
           <a:p>
             <a:pPr indent="0" marL="0">
@@ -32222,10 +32038,10 @@
             <a:r>
               <a:rPr lang="en-US" sz="1300" dirty="0">
                 <a:solidFill>
-                  <a:schemeClr val="tx2"/>
-                </a:solidFill>
-              </a:rPr>
-              <a:t>Solar na rede de distribuição, fora do controle do ONS. Gera no meio do dia.</a:t>
+                  <a:schemeClr val="tx1"/>
+                </a:solidFill>
+              </a:rPr>
+              <a:t>de rampa da carga líquida em 3 h, das 15h às 18h (de 44,1 para 78,0 GW).</a:t>
             </a:r>
             <a:endParaRPr lang="en-US" sz="1300" dirty="0"/>
           </a:p>
@@ -32233,14 +32049,14 @@
       </p:sp>
       <p:sp>
         <p:nvSpPr>
-          <p:cNvPr id="19" name="Definition 3"/>
+          <p:cNvPr id="13" name="Duck stat 3"/>
           <p:cNvSpPr/>
           <p:nvPr/>
         </p:nvSpPr>
         <p:spPr>
           <a:xfrm>
-            <a:off x="7223760" y="4114800"/>
-            <a:ext cx="4419295" cy="1234440"/>
+            <a:off x="7498080" y="4114800"/>
+            <a:ext cx="4144975" cy="1234440"/>
           </a:xfrm>
           <a:prstGeom prst="roundRect">
             <a:avLst>
@@ -32267,63 +32083,41 @@
       </p:sp>
       <p:sp>
         <p:nvSpPr>
-          <p:cNvPr id="20" name="Icon circle"/>
+          <p:cNvPr id="14" name="Duck stat tag 3"/>
           <p:cNvSpPr/>
           <p:nvPr/>
         </p:nvSpPr>
         <p:spPr>
           <a:xfrm>
-            <a:off x="7452360" y="4434840"/>
-            <a:ext cx="548640" cy="548640"/>
-          </a:xfrm>
-          <a:prstGeom prst="ellipse">
-            <a:avLst/>
+            <a:off x="7680960" y="4343400"/>
+            <a:ext cx="1417320" cy="777240"/>
+          </a:xfrm>
+          <a:prstGeom prst="roundRect">
+            <a:avLst>
+              <a:gd name="adj" fmla="val 11765"/>
+            </a:avLst>
           </a:prstGeom>
           <a:solidFill>
-            <a:schemeClr val="accent4"/>
+            <a:schemeClr val="accent3"/>
           </a:solidFill>
           <a:ln w="12700">
             <a:solidFill>
-              <a:schemeClr val="accent4"/>
+              <a:schemeClr val="accent3"/>
             </a:solidFill>
             <a:prstDash val="solid"/>
           </a:ln>
         </p:spPr>
       </p:sp>
-      <p:pic>
-        <p:nvPicPr>
-          <p:cNvPr id="21" name="Image 2" descr="FaChartLine">    </p:cNvPr>
-          <p:cNvPicPr>
-            <a:picLocks noChangeAspect="1"/>
-          </p:cNvPicPr>
-          <p:nvPr/>
-        </p:nvPicPr>
-        <p:blipFill>
-          <a:blip r:embed="rId4"/>
-          <a:stretch>
-            <a:fillRect/>
-          </a:stretch>
-        </p:blipFill>
-        <p:spPr>
-          <a:xfrm>
-            <a:off x="7589520" y="4572000"/>
-            <a:ext cx="274320" cy="274320"/>
-          </a:xfrm>
-          <a:prstGeom prst="rect">
-            <a:avLst/>
-          </a:prstGeom>
-        </p:spPr>
-      </p:pic>
-      <p:sp>
-        <p:nvSpPr>
-          <p:cNvPr id="22" name="Text 16"/>
+      <p:sp>
+        <p:nvSpPr>
+          <p:cNvPr id="15" name="Text 12"/>
           <p:cNvSpPr txBox="1"/>
           <p:nvPr/>
         </p:nvSpPr>
         <p:spPr>
           <a:xfrm>
-            <a:off x="8229600" y="4224528"/>
-            <a:ext cx="3230575" cy="365760"/>
+            <a:off x="7680960" y="4343400"/>
+            <a:ext cx="1417320" cy="777240"/>
           </a:xfrm>
           <a:prstGeom prst="rect">
             <a:avLst/>
@@ -32332,37 +32126,39 @@
           <a:ln/>
         </p:spPr>
         <p:txBody>
-          <a:bodyPr wrap="square" lIns="0" tIns="0" rIns="0" bIns="0" rtlCol="0" anchor="ctr"/>
+          <a:bodyPr wrap="square" lIns="0" tIns="0" rIns="0" bIns="0" rtlCol="0" anchor="ctr">
+            <a:normAutofit/>
+          </a:bodyPr>
           <a:lstStyle/>
           <a:p>
-            <a:pPr indent="0" marL="0">
+            <a:pPr algn="ctr" indent="0" marL="0">
               <a:buNone/>
             </a:pPr>
             <a:r>
-              <a:rPr lang="en-US" sz="1600" b="1" dirty="0">
-                <a:solidFill>
-                  <a:schemeClr val="tx1"/>
+              <a:rPr lang="en-US" sz="2200" b="1" dirty="0">
+                <a:solidFill>
+                  <a:schemeClr val="bg1"/>
                 </a:solidFill>
                 <a:latin typeface="Cambria" pitchFamily="34" charset="0"/>
                 <a:ea typeface="Cambria" pitchFamily="34" charset="-122"/>
                 <a:cs typeface="Cambria" pitchFamily="34" charset="-120"/>
               </a:rPr>
-              <a:t>Carga líquida</a:t>
-            </a:r>
-            <a:endParaRPr lang="en-US" sz="1600" dirty="0"/>
-          </a:p>
-        </p:txBody>
-      </p:sp>
-      <p:sp>
-        <p:nvSpPr>
-          <p:cNvPr id="23" name="Text 17"/>
+              <a:t>0,5 GW</a:t>
+            </a:r>
+            <a:endParaRPr lang="en-US" sz="2200" dirty="0"/>
+          </a:p>
+        </p:txBody>
+      </p:sp>
+      <p:sp>
+        <p:nvSpPr>
+          <p:cNvPr id="16" name="Text 13"/>
           <p:cNvSpPr txBox="1"/>
           <p:nvPr/>
         </p:nvSpPr>
         <p:spPr>
           <a:xfrm>
-            <a:off x="8229600" y="4617720"/>
-            <a:ext cx="3230575" cy="685800"/>
+            <a:off x="9281160" y="4206240"/>
+            <a:ext cx="2179015" cy="1051560"/>
           </a:xfrm>
           <a:prstGeom prst="rect">
             <a:avLst/>
@@ -32371,7 +32167,7 @@
           <a:ln/>
         </p:spPr>
         <p:txBody>
-          <a:bodyPr wrap="square" lIns="0" tIns="0" rIns="0" bIns="0" rtlCol="0" anchor="t"/>
+          <a:bodyPr wrap="square" lIns="0" tIns="0" rIns="0" bIns="0" rtlCol="0" anchor="ctr"/>
           <a:lstStyle/>
           <a:p>
             <a:pPr indent="0" marL="0">
@@ -32380,10 +32176,10 @@
             <a:r>
               <a:rPr lang="en-US" sz="1300" dirty="0">
                 <a:solidFill>
-                  <a:schemeClr val="tx2"/>
-                </a:solidFill>
-              </a:rPr>
-              <a:t>O que sobra para hidrelétricas e térmicas atenderem.</a:t>
+                  <a:schemeClr val="tx1"/>
+                </a:solidFill>
+              </a:rPr>
+              <a:t>geraram as solares centralizadas às 12h, contra 7,3 GW na média de agosto: o excedente forçou cortes.</a:t>
             </a:r>
             <a:endParaRPr lang="en-US" sz="1300" dirty="0"/>
           </a:p>
@@ -32391,18 +32187,18 @@
       </p:sp>
       <p:sp>
         <p:nvSpPr>
-          <p:cNvPr id="24" name="Duck formula banner"/>
+          <p:cNvPr id="17" name="Duck formula banner"/>
           <p:cNvSpPr/>
           <p:nvPr/>
         </p:nvSpPr>
         <p:spPr>
           <a:xfrm>
             <a:off x="548640" y="5532120"/>
-            <a:ext cx="11094415" cy="749808"/>
+            <a:ext cx="11094415" cy="777240"/>
           </a:xfrm>
           <a:prstGeom prst="roundRect">
             <a:avLst>
-              <a:gd name="adj" fmla="val 14634"/>
+              <a:gd name="adj" fmla="val 14118"/>
             </a:avLst>
           </a:prstGeom>
           <a:solidFill>
@@ -32418,14 +32214,14 @@
       </p:sp>
       <p:sp>
         <p:nvSpPr>
-          <p:cNvPr id="25" name="Text 19"/>
+          <p:cNvPr id="18" name="Text 15"/>
           <p:cNvSpPr txBox="1"/>
           <p:nvPr/>
         </p:nvSpPr>
         <p:spPr>
           <a:xfrm>
             <a:off x="822960" y="5532120"/>
-            <a:ext cx="6035040" cy="749808"/>
+            <a:ext cx="10545775" cy="777240"/>
           </a:xfrm>
           <a:prstGeom prst="rect">
             <a:avLst/>
@@ -32441,30 +32237,38 @@
               <a:buNone/>
             </a:pPr>
             <a:r>
-              <a:rPr lang="en-US" sz="1600" b="1" dirty="0">
+              <a:rPr lang="en-US" sz="1400" b="1" dirty="0">
+                <a:solidFill>
+                  <a:schemeClr val="accent1"/>
+                </a:solidFill>
+              </a:rPr>
+              <a:t>Carga líquida = carga bruta − MMGD. </a:t>
+            </a:r>
+            <a:pPr indent="0" marL="0">
+              <a:buNone/>
+            </a:pPr>
+            <a:r>
+              <a:rPr lang="en-US" sz="1400" dirty="0">
                 <a:solidFill>
                   <a:schemeClr val="bg1"/>
                 </a:solidFill>
-                <a:latin typeface="Cambria" pitchFamily="34" charset="0"/>
-                <a:ea typeface="Cambria" pitchFamily="34" charset="-122"/>
-                <a:cs typeface="Cambria" pitchFamily="34" charset="-120"/>
-              </a:rPr>
-              <a:t>Carga líquida = carga bruta − MMGD − eólica − solar centralizada</a:t>
-            </a:r>
-            <a:endParaRPr lang="en-US" sz="1600" dirty="0"/>
-          </a:p>
-        </p:txBody>
-      </p:sp>
-      <p:sp>
-        <p:nvSpPr>
-          <p:cNvPr id="26" name="Text 20"/>
+              </a:rPr>
+              <a:t>A versão ampla também subtrai eólica e solar centralizada. Na média de agosto/2025, a MMGD chegou a 22,4 GW ao meio-dia e a carga líquida foi de 51,9 GW (12h) a 87,8 GW (18h).</a:t>
+            </a:r>
+            <a:endParaRPr lang="en-US" sz="1400" dirty="0"/>
+          </a:p>
+        </p:txBody>
+      </p:sp>
+      <p:sp>
+        <p:nvSpPr>
+          <p:cNvPr id="19" name="Text 16"/>
           <p:cNvSpPr txBox="1"/>
           <p:nvPr/>
         </p:nvSpPr>
         <p:spPr>
           <a:xfrm>
-            <a:off x="7040880" y="5532120"/>
-            <a:ext cx="4327855" cy="749808"/>
+            <a:off x="548640" y="6382512"/>
+            <a:ext cx="10424160" cy="274320"/>
           </a:xfrm>
           <a:prstGeom prst="rect">
             <a:avLst/>
@@ -32480,48 +32284,12 @@
               <a:buNone/>
             </a:pPr>
             <a:r>
-              <a:rPr lang="en-US" sz="1200" dirty="0">
-                <a:solidFill>
-                  <a:schemeClr val="bg1"/>
-                </a:solidFill>
-              </a:rPr>
-              <a:t>Projeção do ONS para 2029: rampas acima de 40 GW em poucas horas, entre 16h30 e 19h. A bateria carrega na barriga e descarrega no pescoço.</a:t>
-            </a:r>
-            <a:endParaRPr lang="en-US" sz="1200" dirty="0"/>
-          </a:p>
-        </p:txBody>
-      </p:sp>
-      <p:sp>
-        <p:nvSpPr>
-          <p:cNvPr id="27" name="Text 21"/>
-          <p:cNvSpPr txBox="1"/>
-          <p:nvPr/>
-        </p:nvSpPr>
-        <p:spPr>
-          <a:xfrm>
-            <a:off x="548640" y="6382512"/>
-            <a:ext cx="10424160" cy="274320"/>
-          </a:xfrm>
-          <a:prstGeom prst="rect">
-            <a:avLst/>
-          </a:prstGeom>
-          <a:noFill/>
-          <a:ln/>
-        </p:spPr>
-        <p:txBody>
-          <a:bodyPr wrap="square" lIns="0" tIns="0" rIns="0" bIns="0" rtlCol="0" anchor="ctr"/>
-          <a:lstStyle/>
-          <a:p>
-            <a:pPr indent="0" marL="0">
-              <a:buNone/>
-            </a:pPr>
-            <a:r>
               <a:rPr lang="en-US" sz="1000" i="1" dirty="0">
                 <a:solidFill>
                   <a:schemeClr val="tx2"/>
                 </a:solidFill>
               </a:rPr>
-              <a:t>Fontes: EPE (2026), base de fluxo de potência do PDE 2035; CAISO (2013), Fast Facts; Ipea; Abraceel (2023). A EPE desconta só a MMGD fotovoltaica, e a versão do setor inclui eólica e solar centralizada.</a:t>
+              <a:t>Fonte: elaboração própria com dados abertos do ONS (balanço de energia e geração por usina, base horária, 2025); MMGD estimada pelo ONS; definição da EPE (2026).</a:t>
             </a:r>
             <a:endParaRPr lang="en-US" sz="1000" dirty="0"/>
           </a:p>

</xml_diff>

<commit_message>
Corrige carga líquida da curva do pato: desconta MMGD, eólica e solar centralizada
Co-Authored-By: Claude Sonnet 5.5 <noreply@anthropic.com>
Claude-Session: https://claude.ai/code/session_018oVMGfcbhG1itrwj795JhB
</commit_message>
<xml_diff>
--- a/Baterias_SIN_Economia_Setor_Eletrico_I.pptx
+++ b/Baterias_SIN_Economia_Setor_Eletrico_I.pptx
@@ -131,12 +131,12 @@
   <p:extLst>
     <p:ext uri="{521415D9-36F7-43E2-AB2F-B90AF26B5E84}">
       <p14:sectionLst xmlns:p14="http://schemas.microsoft.com/office/powerpoint/2010/main">
-        <p14:section name="Abertura" id="{22d14a1a-359c-07cc-bf6c-f406d29c2f44}">
+        <p14:section name="Abertura" id="{2a16064b-dcd0-71f7-ca45-edd8a9c528d9}">
           <p14:sldIdLst>
             <p14:sldId id="256"/>
           </p14:sldIdLst>
         </p14:section>
-        <p14:section name="Introdução" id="{ff90a364-07fa-5700-7b24-b3974b2bbdce}">
+        <p14:section name="Introdução" id="{9308c725-e97d-7995-42fc-0636f346ea33}">
           <p14:sldIdLst>
             <p14:sldId id="257"/>
             <p14:sldId id="258"/>
@@ -145,13 +145,13 @@
             <p14:sldId id="261"/>
           </p14:sldIdLst>
         </p14:section>
-        <p14:section name="Objetivos" id="{b145d3b4-46f3-d0bf-b640-bbd0af6ad0a6}">
+        <p14:section name="Objetivos" id="{3bca2eb7-3ad6-6720-e9a9-740c43a251af}">
           <p14:sldIdLst>
             <p14:sldId id="262"/>
             <p14:sldId id="263"/>
           </p14:sldIdLst>
         </p14:section>
-        <p14:section name="Método" id="{4a15fffa-de2f-08e4-f8e5-cb8b23b29b9f}">
+        <p14:section name="Método" id="{63f8184c-c58d-e6b9-4bdf-f20fecbb676a}">
           <p14:sldIdLst>
             <p14:sldId id="264"/>
             <p14:sldId id="265"/>
@@ -159,13 +159,13 @@
             <p14:sldId id="267"/>
           </p14:sldIdLst>
         </p14:section>
-        <p14:section name="Análise" id="{7055d899-ff08-dc86-96d3-4e366a1d16da}">
+        <p14:section name="Análise" id="{6db83971-e0aa-4f73-577c-0b98e870a772}">
           <p14:sldIdLst>
             <p14:sldId id="268"/>
             <p14:sldId id="269"/>
           </p14:sldIdLst>
         </p14:section>
-        <p14:section name="Encargos e benefícios" id="{c464c56f-cfd6-fb6b-75cc-b4faacc37738}">
+        <p14:section name="Encargos e benefícios" id="{c327c3c6-2d13-830d-dd63-056c9b787312}">
           <p14:sldIdLst>
             <p14:sldId id="270"/>
             <p14:sldId id="271"/>
@@ -178,7 +178,7 @@
             <p14:sldId id="278"/>
           </p14:sldIdLst>
         </p14:section>
-        <p14:section name="Fechamento" id="{452ce5d8-ce11-c07b-94de-08d60050caf0}">
+        <p14:section name="Fechamento" id="{496b3457-0153-2e6c-acec-733c789f968d}">
           <p14:sldIdLst>
             <p14:sldId id="279"/>
             <p14:sldId id="280"/>
@@ -709,18 +709,18 @@
               <c:strCache>
                 <c:ptCount val="1"/>
                 <c:pt idx="0">
-                  <c:v>Carga líquida (bruta − MMGD)</c:v>
+                  <c:v>Eólica e solar centralizada</c:v>
                 </c:pt>
               </c:strCache>
             </c:strRef>
           </c:tx>
           <c:spPr>
             <a:solidFill>
-              <a:srgbClr val="E4572E"/>
+              <a:srgbClr val="1FB5A8"/>
             </a:solidFill>
             <a:ln w="38100" cap="flat">
               <a:solidFill>
-                <a:srgbClr val="E4572E"/>
+                <a:srgbClr val="1FB5A8"/>
               </a:solidFill>
               <a:prstDash val="solid"/>
               <a:round/>
@@ -757,11 +757,11 @@
             <c:size val="6"/>
             <c:spPr>
               <a:solidFill>
-                <a:srgbClr val="E4572E"/>
+                <a:srgbClr val="1FB5A8"/>
               </a:solidFill>
               <a:ln w="9525" cap="flat">
                 <a:solidFill>
-                  <a:srgbClr val="E4572E"/>
+                  <a:srgbClr val="1FB5A8"/>
                 </a:solidFill>
                 <a:prstDash val="solid"/>
                 <a:round/>
@@ -858,76 +858,310 @@
                 <c:formatCode>General</c:formatCode>
                 <c:ptCount val="24"/>
                 <c:pt idx="0">
-                  <c:v>65.13</c:v>
+                  <c:v>14.15</c:v>
                 </c:pt>
                 <c:pt idx="1">
-                  <c:v>61.87</c:v>
+                  <c:v>14.33</c:v>
                 </c:pt>
                 <c:pt idx="2">
-                  <c:v>59.65</c:v>
+                  <c:v>13.95</c:v>
                 </c:pt>
                 <c:pt idx="3">
+                  <c:v>13.35</c:v>
+                </c:pt>
+                <c:pt idx="4">
+                  <c:v>12.37</c:v>
+                </c:pt>
+                <c:pt idx="5">
+                  <c:v>11.95</c:v>
+                </c:pt>
+                <c:pt idx="6">
+                  <c:v>12.48</c:v>
+                </c:pt>
+                <c:pt idx="7">
+                  <c:v>11.08</c:v>
+                </c:pt>
+                <c:pt idx="8">
+                  <c:v>7.94</c:v>
+                </c:pt>
+                <c:pt idx="9">
+                  <c:v>4.41</c:v>
+                </c:pt>
+                <c:pt idx="10">
+                  <c:v>2.72</c:v>
+                </c:pt>
+                <c:pt idx="11">
+                  <c:v>1.77</c:v>
+                </c:pt>
+                <c:pt idx="12">
+                  <c:v>1.09</c:v>
+                </c:pt>
+                <c:pt idx="13">
+                  <c:v>0.97</c:v>
+                </c:pt>
+                <c:pt idx="14">
+                  <c:v>2.11</c:v>
+                </c:pt>
+                <c:pt idx="15">
+                  <c:v>6.8</c:v>
+                </c:pt>
+                <c:pt idx="16">
+                  <c:v>11.91</c:v>
+                </c:pt>
+                <c:pt idx="17">
+                  <c:v>10.87</c:v>
+                </c:pt>
+                <c:pt idx="18">
+                  <c:v>10.78</c:v>
+                </c:pt>
+                <c:pt idx="19">
+                  <c:v>11.47</c:v>
+                </c:pt>
+                <c:pt idx="20">
+                  <c:v>12.1</c:v>
+                </c:pt>
+                <c:pt idx="21">
+                  <c:v>12.21</c:v>
+                </c:pt>
+                <c:pt idx="22">
+                  <c:v>13.4</c:v>
+                </c:pt>
+                <c:pt idx="23">
+                  <c:v>15.6</c:v>
+                </c:pt>
+              </c:numCache>
+            </c:numRef>
+          </c:val>
+          <c:smooth val="0"/>
+        </c:ser>
+        <c:ser>
+          <c:idx val="3"/>
+          <c:order val="3"/>
+          <c:tx>
+            <c:strRef>
+              <c:f>Sheet1!$E$1</c:f>
+              <c:strCache>
+                <c:ptCount val="1"/>
+                <c:pt idx="0">
+                  <c:v>Carga líquida</c:v>
+                </c:pt>
+              </c:strCache>
+            </c:strRef>
+          </c:tx>
+          <c:spPr>
+            <a:solidFill>
+              <a:srgbClr val="E4572E"/>
+            </a:solidFill>
+            <a:ln w="38100" cap="flat">
+              <a:solidFill>
+                <a:srgbClr val="E4572E"/>
+              </a:solidFill>
+              <a:prstDash val="solid"/>
+              <a:round/>
+            </a:ln>
+            <a:effectLst/>
+          </c:spPr>
+          <c:invertIfNegative val="0"/>
+          <c:dLbls>
+            <c:numFmt formatCode="#,##0" sourceLinked="0"/>
+            <c:txPr>
+              <a:bodyPr/>
+              <a:lstStyle/>
+              <a:p>
+                <a:pPr>
+                  <a:defRPr b="0" i="0" strike="noStrike" sz="1200" u="none">
+                    <a:solidFill>
+                      <a:srgbClr val="000000"/>
+                    </a:solidFill>
+                    <a:latin typeface="Arial"/>
+                  </a:defRPr>
+                </a:pPr>
+              </a:p>
+            </c:txPr>
+            <c:showLegendKey val="0"/>
+            <c:showVal val="0"/>
+            <c:showCatName val="0"/>
+            <c:showSerName val="0"/>
+            <c:showPercent val="0"/>
+            <c:showBubbleSize val="0"/>
+            <c:showLeaderLines val="0"/>
+          </c:dLbls>
+          <c:marker>
+            <c:symbol val="none"/>
+            <c:size val="6"/>
+            <c:spPr>
+              <a:solidFill>
+                <a:srgbClr val="E4572E"/>
+              </a:solidFill>
+              <a:ln w="9525" cap="flat">
+                <a:solidFill>
+                  <a:srgbClr val="E4572E"/>
+                </a:solidFill>
+                <a:prstDash val="solid"/>
+                <a:round/>
+              </a:ln>
+              <a:effectLst/>
+            </c:spPr>
+          </c:marker>
+          <c:cat>
+            <c:multiLvlStrRef>
+              <c:f>Sheet1!$A$2:$A$25</c:f>
+              <c:multiLvlStrCache>
+                <c:ptCount val="24"/>
+                <c:lvl>
+                  <c:pt idx="0">
+                    <c:v>0h</c:v>
+                  </c:pt>
+                  <c:pt idx="1">
+                    <c:v> </c:v>
+                  </c:pt>
+                  <c:pt idx="2">
+                    <c:v>  </c:v>
+                  </c:pt>
+                  <c:pt idx="3">
+                    <c:v>3h</c:v>
+                  </c:pt>
+                  <c:pt idx="4">
+                    <c:v> </c:v>
+                  </c:pt>
+                  <c:pt idx="5">
+                    <c:v>  </c:v>
+                  </c:pt>
+                  <c:pt idx="6">
+                    <c:v>6h</c:v>
+                  </c:pt>
+                  <c:pt idx="7">
+                    <c:v> </c:v>
+                  </c:pt>
+                  <c:pt idx="8">
+                    <c:v>  </c:v>
+                  </c:pt>
+                  <c:pt idx="9">
+                    <c:v>9h</c:v>
+                  </c:pt>
+                  <c:pt idx="10">
+                    <c:v> </c:v>
+                  </c:pt>
+                  <c:pt idx="11">
+                    <c:v>  </c:v>
+                  </c:pt>
+                  <c:pt idx="12">
+                    <c:v>12h</c:v>
+                  </c:pt>
+                  <c:pt idx="13">
+                    <c:v> </c:v>
+                  </c:pt>
+                  <c:pt idx="14">
+                    <c:v>  </c:v>
+                  </c:pt>
+                  <c:pt idx="15">
+                    <c:v>15h</c:v>
+                  </c:pt>
+                  <c:pt idx="16">
+                    <c:v> </c:v>
+                  </c:pt>
+                  <c:pt idx="17">
+                    <c:v>  </c:v>
+                  </c:pt>
+                  <c:pt idx="18">
+                    <c:v>18h</c:v>
+                  </c:pt>
+                  <c:pt idx="19">
+                    <c:v> </c:v>
+                  </c:pt>
+                  <c:pt idx="20">
+                    <c:v>  </c:v>
+                  </c:pt>
+                  <c:pt idx="21">
+                    <c:v>21h</c:v>
+                  </c:pt>
+                  <c:pt idx="22">
+                    <c:v> </c:v>
+                  </c:pt>
+                  <c:pt idx="23">
+                    <c:v>  </c:v>
+                  </c:pt>
+                </c:lvl>
+              </c:multiLvlStrCache>
+            </c:multiLvlStrRef>
+          </c:cat>
+          <c:val>
+            <c:numRef>
+              <c:f>Sheet1!$E$2:$E$25</c:f>
+              <c:numCache>
+                <c:formatCode>General</c:formatCode>
+                <c:ptCount val="24"/>
+                <c:pt idx="0">
+                  <c:v>50.98</c:v>
+                </c:pt>
+                <c:pt idx="1">
+                  <c:v>47.54</c:v>
+                </c:pt>
+                <c:pt idx="2">
+                  <c:v>45.7</c:v>
+                </c:pt>
+                <c:pt idx="3">
+                  <c:v>44.88</c:v>
+                </c:pt>
+                <c:pt idx="4">
+                  <c:v>45.1</c:v>
+                </c:pt>
+                <c:pt idx="5">
+                  <c:v>44.88</c:v>
+                </c:pt>
+                <c:pt idx="6">
+                  <c:v>42.43</c:v>
+                </c:pt>
+                <c:pt idx="7">
+                  <c:v>39.62</c:v>
+                </c:pt>
+                <c:pt idx="8">
+                  <c:v>37.18</c:v>
+                </c:pt>
+                <c:pt idx="9">
+                  <c:v>36.21</c:v>
+                </c:pt>
+                <c:pt idx="10">
+                  <c:v>35.56</c:v>
+                </c:pt>
+                <c:pt idx="11">
+                  <c:v>35.46</c:v>
+                </c:pt>
+                <c:pt idx="12">
+                  <c:v>34.67</c:v>
+                </c:pt>
+                <c:pt idx="13">
+                  <c:v>34.5</c:v>
+                </c:pt>
+                <c:pt idx="14">
+                  <c:v>35.8</c:v>
+                </c:pt>
+                <c:pt idx="15">
+                  <c:v>37.3</c:v>
+                </c:pt>
+                <c:pt idx="16">
+                  <c:v>42.41</c:v>
+                </c:pt>
+                <c:pt idx="17">
+                  <c:v>56.53</c:v>
+                </c:pt>
+                <c:pt idx="18">
+                  <c:v>67.22</c:v>
+                </c:pt>
+                <c:pt idx="19">
+                  <c:v>66.73</c:v>
+                </c:pt>
+                <c:pt idx="20">
+                  <c:v>64.38</c:v>
+                </c:pt>
+                <c:pt idx="21">
+                  <c:v>62.68</c:v>
+                </c:pt>
+                <c:pt idx="22">
                   <c:v>58.23</c:v>
                 </c:pt>
-                <c:pt idx="4">
-                  <c:v>57.47</c:v>
-                </c:pt>
-                <c:pt idx="5">
-                  <c:v>56.82</c:v>
-                </c:pt>
-                <c:pt idx="6">
-                  <c:v>54.91</c:v>
-                </c:pt>
-                <c:pt idx="7">
-                  <c:v>50.7</c:v>
-                </c:pt>
-                <c:pt idx="8">
-                  <c:v>45.12</c:v>
-                </c:pt>
-                <c:pt idx="9">
-                  <c:v>40.62</c:v>
-                </c:pt>
-                <c:pt idx="10">
-                  <c:v>38.29</c:v>
-                </c:pt>
-                <c:pt idx="11">
-                  <c:v>37.23</c:v>
-                </c:pt>
-                <c:pt idx="12">
-                  <c:v>35.76</c:v>
-                </c:pt>
-                <c:pt idx="13">
-                  <c:v>35.47</c:v>
-                </c:pt>
-                <c:pt idx="14">
-                  <c:v>37.91</c:v>
-                </c:pt>
-                <c:pt idx="15">
-                  <c:v>44.11</c:v>
-                </c:pt>
-                <c:pt idx="16">
-                  <c:v>54.32</c:v>
-                </c:pt>
-                <c:pt idx="17">
-                  <c:v>67.4</c:v>
-                </c:pt>
-                <c:pt idx="18">
-                  <c:v>78</c:v>
-                </c:pt>
-                <c:pt idx="19">
-                  <c:v>78.2</c:v>
-                </c:pt>
-                <c:pt idx="20">
-                  <c:v>76.48</c:v>
-                </c:pt>
-                <c:pt idx="21">
-                  <c:v>74.89</c:v>
-                </c:pt>
-                <c:pt idx="22">
-                  <c:v>71.63</c:v>
-                </c:pt>
                 <c:pt idx="23">
-                  <c:v>67.38</c:v>
+                  <c:v>51.78</c:v>
                 </c:pt>
               </c:numCache>
             </c:numRef>
@@ -3914,7 +4148,7 @@
           <a:p>
             <a:r>
               <a:rPr lang="en-US" dirty="0"/>
-              <a:t>Curva real do SIN em 10/08/2025, um domingo e o dia do episódio de excedente citado pelo setor. Os dados são os dados abertos do ONS em base horária: a carga vem do balanço de energia nos subsistemas (linha SIN), e a MMGD é a modalidade 'Pequenas Usinas (MMGD)' do conjunto de geração por usina, que é uma estimativa do ONS. A soma de MMGD e solar centralizada reproduz a geração solar do balanço, e a geração total reproduz a carga, o que indica que a carga do ONS é a carga bruta, incluindo a parcela atendida pela MMGD. Carga líquida = carga bruta menos MMGD, que é a definição da EPE; a versão ampla também desconta eólica e solar centralizada. Resultados do dia: MMGD de 23,2 GW às 12h, equivalente a 39,4% da carga de 59,0 GW; carga líquida mínima de 35,5 GW às 13h e máxima de 78,2 GW às 19h; rampa de 33,9 GW entre 15h e 18h. A solar centralizada gerou 0,5 GW às 12h, contra 7,3 GW na média de agosto. A média de agosto/2025 (31 dias) mostra o mesmo formato, com carga líquida de 51,9 GW às 12h e 87,8 GW às 18h.</a:t>
+              <a:t>Curva real do SIN em 10/08/2025, um domingo e o dia do episódio de excedente citado pelo setor. Dados abertos do ONS em base horária: a carga vem do balanço de energia nos subsistemas (linha SIN), e a MMGD é a modalidade 'Pequenas Usinas (MMGD)' do conjunto de geração por usina, que é uma estimativa do ONS. A soma de MMGD e solar centralizada reproduz a geração solar do balanço, e a geração total reproduz a carga, o que indica que a carga do ONS é a carga bruta, incluindo a parcela atendida pela MMGD. Carga líquida = carga bruta menos MMGD, menos geração eólica e menos solar centralizada; o gráfico calcula as quatro curvas a partir da mesma base, e a identidade fecha com erro máximo de 0,02 GW por arredondamento. Não são descontadas outras fontes não despacháveis, como PCHs, biomassa e térmicas inflexíveis. Atenção: a eólica e a solar centralizada usadas são as efetivamente geradas, já com os cortes; no dia 10/08 elas somaram apenas 1,1 GW às 12h, contra 14,3 GW na média de agosto, então parte da barriga da carga líquida estaria ainda mais profunda sem os cortes. Resultados do dia: MMGD de 23,2 GW às 12h, equivalente a 39,4% da carga de 59,0 GW; carga líquida mínima de 34,5 GW às 13h e máxima de 67,2 GW às 18h; rampa de 29,9 GW entre 15h e 18h. A média de agosto/2025 (31 dias) tem o mesmo formato: carga líquida de 37,7 GW às 12h e 70,7 GW às 18h.</a:t>
             </a:r>
             <a:endParaRPr lang="en-US" dirty="0"/>
           </a:p>
@@ -32005,7 +32239,7 @@
                 <a:ea typeface="Cambria" pitchFamily="34" charset="-122"/>
                 <a:cs typeface="Cambria" pitchFamily="34" charset="-120"/>
               </a:rPr>
-              <a:t>+34 GW</a:t>
+              <a:t>+30 GW</a:t>
             </a:r>
             <a:endParaRPr lang="en-US" sz="2200" dirty="0"/>
           </a:p>
@@ -32041,7 +32275,7 @@
                   <a:schemeClr val="tx1"/>
                 </a:solidFill>
               </a:rPr>
-              <a:t>de rampa da carga líquida em 3 h, das 15h às 18h (de 44,1 para 78,0 GW).</a:t>
+              <a:t>de rampa da carga líquida em 3 h, das 15h às 18h (de 37,3 para 67,2 GW).</a:t>
             </a:r>
             <a:endParaRPr lang="en-US" sz="1300" dirty="0"/>
           </a:p>
@@ -32098,11 +32332,11 @@
             </a:avLst>
           </a:prstGeom>
           <a:solidFill>
-            <a:schemeClr val="accent3"/>
+            <a:schemeClr val="accent2"/>
           </a:solidFill>
           <a:ln w="12700">
             <a:solidFill>
-              <a:schemeClr val="accent3"/>
+              <a:schemeClr val="accent2"/>
             </a:solidFill>
             <a:prstDash val="solid"/>
           </a:ln>
@@ -32137,13 +32371,13 @@
             <a:r>
               <a:rPr lang="en-US" sz="2200" b="1" dirty="0">
                 <a:solidFill>
-                  <a:schemeClr val="bg1"/>
+                  <a:schemeClr val="tx1"/>
                 </a:solidFill>
                 <a:latin typeface="Cambria" pitchFamily="34" charset="0"/>
                 <a:ea typeface="Cambria" pitchFamily="34" charset="-122"/>
                 <a:cs typeface="Cambria" pitchFamily="34" charset="-120"/>
               </a:rPr>
-              <a:t>0,5 GW</a:t>
+              <a:t>1,1 GW</a:t>
             </a:r>
             <a:endParaRPr lang="en-US" sz="2200" dirty="0"/>
           </a:p>
@@ -32179,7 +32413,7 @@
                   <a:schemeClr val="tx1"/>
                 </a:solidFill>
               </a:rPr>
-              <a:t>geraram as solares centralizadas às 12h, contra 7,3 GW na média de agosto: o excedente forçou cortes.</a:t>
+              <a:t>geraram eólicas e solares centralizadas às 12h, contra 14,3 GW na média de agosto: o excedente forçou cortes.</a:t>
             </a:r>
             <a:endParaRPr lang="en-US" sz="1300" dirty="0"/>
           </a:p>
@@ -32242,7 +32476,7 @@
                   <a:schemeClr val="accent1"/>
                 </a:solidFill>
               </a:rPr>
-              <a:t>Carga líquida = carga bruta − MMGD. </a:t>
+              <a:t>Carga líquida = carga bruta − MMGD − eólica − solar centralizada. </a:t>
             </a:r>
             <a:pPr indent="0" marL="0">
               <a:buNone/>
@@ -32253,7 +32487,7 @@
                   <a:schemeClr val="bg1"/>
                 </a:solidFill>
               </a:rPr>
-              <a:t>A versão ampla também subtrai eólica e solar centralizada. Na média de agosto/2025, a MMGD chegou a 22,4 GW ao meio-dia e a carga líquida foi de 51,9 GW (12h) a 87,8 GW (18h).</a:t>
+              <a:t>No dia 10/08, caiu a 34,7 GW às 12h (59% da carga bruta) e chegou a 67,2 GW às 18h. Média de agosto/2025: de 37,7 GW (12h) a 70,7 GW (18h).</a:t>
             </a:r>
             <a:endParaRPr lang="en-US" sz="1400" dirty="0"/>
           </a:p>
@@ -32289,7 +32523,7 @@
                   <a:schemeClr val="tx2"/>
                 </a:solidFill>
               </a:rPr>
-              <a:t>Fonte: elaboração própria com dados abertos do ONS (balanço de energia e geração por usina, base horária, 2025); MMGD estimada pelo ONS; definição da EPE (2026).</a:t>
+              <a:t>Fonte: elaboração própria com dados abertos do ONS (balanço de energia e geração por usina, base horária, 2025); MMGD estimada pelo ONS. Termo popularizado pelo CAISO (2013).</a:t>
             </a:r>
             <a:endParaRPr lang="en-US" sz="1000" dirty="0"/>
           </a:p>

</xml_diff>

<commit_message>
Slide 4: mostra geração de eólicas e solares às 12h sem cortes (10/08/2025)
Co-Authored-By: Claude Sonnet 5.5 <noreply@anthropic.com>
Claude-Session: https://claude.ai/code/session_018oVMGfcbhG1itrwj795JhB
</commit_message>
<xml_diff>
--- a/Baterias_SIN_Economia_Setor_Eletrico_I.pptx
+++ b/Baterias_SIN_Economia_Setor_Eletrico_I.pptx
@@ -131,12 +131,12 @@
   <p:extLst>
     <p:ext uri="{521415D9-36F7-43E2-AB2F-B90AF26B5E84}">
       <p14:sectionLst xmlns:p14="http://schemas.microsoft.com/office/powerpoint/2010/main">
-        <p14:section name="Abertura" id="{2a16064b-dcd0-71f7-ca45-edd8a9c528d9}">
+        <p14:section name="Abertura" id="{1a2d4c0a-b890-c880-0039-e60a76593e2a}">
           <p14:sldIdLst>
             <p14:sldId id="256"/>
           </p14:sldIdLst>
         </p14:section>
-        <p14:section name="Introdução" id="{9308c725-e97d-7995-42fc-0636f346ea33}">
+        <p14:section name="Introdução" id="{07f448da-0587-3a8a-16a7-10c211cb14af}">
           <p14:sldIdLst>
             <p14:sldId id="257"/>
             <p14:sldId id="258"/>
@@ -145,13 +145,13 @@
             <p14:sldId id="261"/>
           </p14:sldIdLst>
         </p14:section>
-        <p14:section name="Objetivos" id="{3bca2eb7-3ad6-6720-e9a9-740c43a251af}">
+        <p14:section name="Objetivos" id="{542f5a89-0154-bba7-fa22-981b2029a50c}">
           <p14:sldIdLst>
             <p14:sldId id="262"/>
             <p14:sldId id="263"/>
           </p14:sldIdLst>
         </p14:section>
-        <p14:section name="Método" id="{63f8184c-c58d-e6b9-4bdf-f20fecbb676a}">
+        <p14:section name="Método" id="{1080dd48-39f9-824d-87b5-97916fd7a6ce}">
           <p14:sldIdLst>
             <p14:sldId id="264"/>
             <p14:sldId id="265"/>
@@ -159,13 +159,13 @@
             <p14:sldId id="267"/>
           </p14:sldIdLst>
         </p14:section>
-        <p14:section name="Análise" id="{6db83971-e0aa-4f73-577c-0b98e870a772}">
+        <p14:section name="Análise" id="{b6bd59b5-7ad3-12e0-6e2b-ae8551d41982}">
           <p14:sldIdLst>
             <p14:sldId id="268"/>
             <p14:sldId id="269"/>
           </p14:sldIdLst>
         </p14:section>
-        <p14:section name="Encargos e benefícios" id="{c327c3c6-2d13-830d-dd63-056c9b787312}">
+        <p14:section name="Encargos e benefícios" id="{ab62028d-bc8e-2b38-1484-2c66b91c5667}">
           <p14:sldIdLst>
             <p14:sldId id="270"/>
             <p14:sldId id="271"/>
@@ -178,7 +178,7 @@
             <p14:sldId id="278"/>
           </p14:sldIdLst>
         </p14:section>
-        <p14:section name="Fechamento" id="{496b3457-0153-2e6c-acec-733c789f968d}">
+        <p14:section name="Fechamento" id="{00a5d4fb-8b18-48c1-7e91-4980bc5b3b4d}">
           <p14:sldIdLst>
             <p14:sldId id="279"/>
             <p14:sldId id="280"/>
@@ -4148,7 +4148,7 @@
           <a:p>
             <a:r>
               <a:rPr lang="en-US" dirty="0"/>
-              <a:t>Curva real do SIN em 10/08/2025, um domingo e o dia do episódio de excedente citado pelo setor. Dados abertos do ONS em base horária: a carga vem do balanço de energia nos subsistemas (linha SIN), e a MMGD é a modalidade 'Pequenas Usinas (MMGD)' do conjunto de geração por usina, que é uma estimativa do ONS. A soma de MMGD e solar centralizada reproduz a geração solar do balanço, e a geração total reproduz a carga, o que indica que a carga do ONS é a carga bruta, incluindo a parcela atendida pela MMGD. Carga líquida = carga bruta menos MMGD, menos geração eólica e menos solar centralizada; o gráfico calcula as quatro curvas a partir da mesma base, e a identidade fecha com erro máximo de 0,02 GW por arredondamento. Não são descontadas outras fontes não despacháveis, como PCHs, biomassa e térmicas inflexíveis. Atenção: a eólica e a solar centralizada usadas são as efetivamente geradas, já com os cortes; no dia 10/08 elas somaram apenas 1,1 GW às 12h, contra 14,3 GW na média de agosto, então parte da barriga da carga líquida estaria ainda mais profunda sem os cortes. Resultados do dia: MMGD de 23,2 GW às 12h, equivalente a 39,4% da carga de 59,0 GW; carga líquida mínima de 34,5 GW às 13h e máxima de 67,2 GW às 18h; rampa de 29,9 GW entre 15h e 18h. A média de agosto/2025 (31 dias) tem o mesmo formato: carga líquida de 37,7 GW às 12h e 70,7 GW às 18h.</a:t>
+              <a:t>Curva real do SIN em 10/08/2025, um domingo e o dia do episódio de excedente citado pelo setor. Dados abertos do ONS em base horária: a carga vem do balanço de energia nos subsistemas (linha SIN), e a MMGD é a modalidade 'Pequenas Usinas (MMGD)' do conjunto de geração por usina, que é uma estimativa do ONS. A soma de MMGD e solar centralizada reproduz a geração solar do balanço, e a geração total reproduz a carga, o que indica que a carga do ONS é a carga bruta, incluindo a parcela atendida pela MMGD. Carga líquida = carga bruta menos MMGD, menos geração eólica e menos solar centralizada; o gráfico calcula as quatro curvas a partir da mesma base, e a identidade fecha com erro máximo de 0,02 GW por arredondamento. Não são descontadas outras fontes não despacháveis, como PCHs, biomassa e térmicas inflexíveis. Atenção: a eólica e a solar centralizada descontadas no gráfico são as efetivamente geradas, já com os cortes. Às 12h de 10/08 elas geraram 1,09 GW (eólica 0,62 e solar 0,47). Sem cortes, seriam 18,6 GW: a geração não realizada apurada pelo ONS por razão energética foi de 4,53 GW na eólica e 12,99 GW na solar centralizada (conjunto de restrição do ONS, média das leituras de 12h00 e 12h30), o que dá 5,15 GW de eólica e 13,46 GW de solar, e 94% de corte. Os 18,6 GW somam a geração realizada do arquivo por usina e o corte apurado no arquivo de restrição; os dois arquivos cobrem conjuntos de usinas diferentes, então a soma é uma estimativa. Resultados do dia: MMGD de 23,2 GW às 12h, equivalente a 39,4% da carga de 59,0 GW; carga líquida mínima de 34,5 GW às 13h e máxima de 67,2 GW às 18h; rampa de 29,9 GW entre 15h e 18h. A média de agosto/2025 (31 dias) tem o mesmo formato: carga líquida de 37,7 GW às 12h e 70,7 GW às 18h.</a:t>
             </a:r>
             <a:endParaRPr lang="en-US" dirty="0"/>
           </a:p>
@@ -32377,7 +32377,7 @@
                 <a:ea typeface="Cambria" pitchFamily="34" charset="-122"/>
                 <a:cs typeface="Cambria" pitchFamily="34" charset="-120"/>
               </a:rPr>
-              <a:t>1,1 GW</a:t>
+              <a:t>18,6 GW</a:t>
             </a:r>
             <a:endParaRPr lang="en-US" sz="2200" dirty="0"/>
           </a:p>
@@ -32413,7 +32413,7 @@
                   <a:schemeClr val="tx1"/>
                 </a:solidFill>
               </a:rPr>
-              <a:t>geraram eólicas e solares centralizadas às 12h, contra 14,3 GW na média de agosto: o excedente forçou cortes.</a:t>
+              <a:t>seriam gerados por eólicas (5,1) e solares centralizadas (13,5) às 12h sem cortes. Geraram só 1,1 GW: 94% foi cortado.</a:t>
             </a:r>
             <a:endParaRPr lang="en-US" sz="1300" dirty="0"/>
           </a:p>
@@ -32523,7 +32523,7 @@
                   <a:schemeClr val="tx2"/>
                 </a:solidFill>
               </a:rPr>
-              <a:t>Fonte: elaboração própria com dados abertos do ONS (balanço de energia e geração por usina, base horária, 2025); MMGD estimada pelo ONS. Termo popularizado pelo CAISO (2013).</a:t>
+              <a:t>Fonte: elaboração própria com dados abertos do ONS (balanço, geração por usina e restrições de eólicas e solares, 2025); MMGD estimada pelo ONS.</a:t>
             </a:r>
             <a:endParaRPr lang="en-US" sz="1000" dirty="0"/>
           </a:p>

</xml_diff>